<commit_message>
Final version of presentation
</commit_message>
<xml_diff>
--- a/presentations/INIPresentation_JL.pptx
+++ b/presentations/INIPresentation_JL.pptx
@@ -5,7 +5,7 @@
     <p:sldMasterId id="2147483648" r:id="rId1"/>
   </p:sldMasterIdLst>
   <p:notesMasterIdLst>
-    <p:notesMasterId r:id="rId39"/>
+    <p:notesMasterId r:id="rId38"/>
   </p:notesMasterIdLst>
   <p:sldIdLst>
     <p:sldId id="2188" r:id="rId2"/>
@@ -39,12 +39,11 @@
     <p:sldId id="2318" r:id="rId30"/>
     <p:sldId id="2338" r:id="rId31"/>
     <p:sldId id="2370" r:id="rId32"/>
-    <p:sldId id="2362" r:id="rId33"/>
-    <p:sldId id="2355" r:id="rId34"/>
-    <p:sldId id="2273" r:id="rId35"/>
-    <p:sldId id="2272" r:id="rId36"/>
-    <p:sldId id="2353" r:id="rId37"/>
-    <p:sldId id="2354" r:id="rId38"/>
+    <p:sldId id="328" r:id="rId33"/>
+    <p:sldId id="2362" r:id="rId34"/>
+    <p:sldId id="2355" r:id="rId35"/>
+    <p:sldId id="2273" r:id="rId36"/>
+    <p:sldId id="2272" r:id="rId37"/>
   </p:sldIdLst>
   <p:sldSz cx="12192000" cy="6858000"/>
   <p:notesSz cx="6858000" cy="9144000"/>
@@ -877,6 +876,93 @@
 </p:notes>
 </file>
 
+<file path=ppt/notesSlides/notesSlide10.xml><?xml version="1.0" encoding="utf-8"?>
+<p:notes xmlns:a="http://schemas.openxmlformats.org/drawingml/2006/main" xmlns:r="http://schemas.openxmlformats.org/officeDocument/2006/relationships" xmlns:p="http://schemas.openxmlformats.org/presentationml/2006/main">
+  <p:cSld>
+    <p:spTree>
+      <p:nvGrpSpPr>
+        <p:cNvPr id="1" name=""/>
+        <p:cNvGrpSpPr/>
+        <p:nvPr/>
+      </p:nvGrpSpPr>
+      <p:grpSpPr>
+        <a:xfrm>
+          <a:off x="0" y="0"/>
+          <a:ext cx="0" cy="0"/>
+          <a:chOff x="0" y="0"/>
+          <a:chExt cx="0" cy="0"/>
+        </a:xfrm>
+      </p:grpSpPr>
+      <p:sp>
+        <p:nvSpPr>
+          <p:cNvPr id="2" name="Slide Image Placeholder 1"/>
+          <p:cNvSpPr>
+            <a:spLocks noGrp="1" noRot="1" noChangeAspect="1"/>
+          </p:cNvSpPr>
+          <p:nvPr>
+            <p:ph type="sldImg"/>
+          </p:nvPr>
+        </p:nvSpPr>
+        <p:spPr/>
+      </p:sp>
+      <p:sp>
+        <p:nvSpPr>
+          <p:cNvPr id="3" name="Notes Placeholder 2"/>
+          <p:cNvSpPr>
+            <a:spLocks noGrp="1"/>
+          </p:cNvSpPr>
+          <p:nvPr>
+            <p:ph type="body" idx="1"/>
+          </p:nvPr>
+        </p:nvSpPr>
+        <p:spPr/>
+        <p:txBody>
+          <a:bodyPr/>
+          <a:lstStyle/>
+          <a:p>
+            <a:r>
+              <a:rPr lang="en-US" dirty="0"/>
+              <a:t>Does this capture different goals and trying to do most of these simultaneously leads to tensions and challenges. </a:t>
+            </a:r>
+          </a:p>
+        </p:txBody>
+      </p:sp>
+      <p:sp>
+        <p:nvSpPr>
+          <p:cNvPr id="4" name="Slide Number Placeholder 3"/>
+          <p:cNvSpPr>
+            <a:spLocks noGrp="1"/>
+          </p:cNvSpPr>
+          <p:nvPr>
+            <p:ph type="sldNum" sz="quarter" idx="5"/>
+          </p:nvPr>
+        </p:nvSpPr>
+        <p:spPr/>
+        <p:txBody>
+          <a:bodyPr/>
+          <a:lstStyle/>
+          <a:p>
+            <a:fld id="{E9958A4D-8FF3-450F-970B-2BB1244E94FF}" type="slidenum">
+              <a:rPr lang="en-US" smtClean="0"/>
+              <a:t>35</a:t>
+            </a:fld>
+            <a:endParaRPr lang="en-US"/>
+          </a:p>
+        </p:txBody>
+      </p:sp>
+    </p:spTree>
+    <p:extLst>
+      <p:ext uri="{BB962C8B-B14F-4D97-AF65-F5344CB8AC3E}">
+        <p14:creationId xmlns:p14="http://schemas.microsoft.com/office/powerpoint/2010/main" val="4196810274"/>
+      </p:ext>
+    </p:extLst>
+  </p:cSld>
+  <p:clrMapOvr>
+    <a:masterClrMapping/>
+  </p:clrMapOvr>
+</p:notes>
+</file>
+
 <file path=ppt/notesSlides/notesSlide2.xml><?xml version="1.0" encoding="utf-8"?>
 <p:notes xmlns:a="http://schemas.openxmlformats.org/drawingml/2006/main" xmlns:r="http://schemas.openxmlformats.org/officeDocument/2006/relationships" xmlns:p="http://schemas.openxmlformats.org/presentationml/2006/main">
   <p:cSld>
@@ -1515,10 +1601,7 @@
           <a:bodyPr/>
           <a:lstStyle/>
           <a:p>
-            <a:r>
-              <a:rPr lang="en-US" dirty="0"/>
-              <a:t>Does this capture different goals and trying to do most of these simultaneously leads to tensions and challenges. </a:t>
-            </a:r>
+            <a:endParaRPr lang="en-US" dirty="0"/>
           </a:p>
         </p:txBody>
       </p:sp>
@@ -1537,9 +1620,9 @@
           <a:bodyPr/>
           <a:lstStyle/>
           <a:p>
-            <a:fld id="{E9958A4D-8FF3-450F-970B-2BB1244E94FF}" type="slidenum">
+            <a:fld id="{4D3DA4A9-580A-764A-8739-4EEBA1CA1B72}" type="slidenum">
               <a:rPr lang="en-US" smtClean="0"/>
-              <a:t>34</a:t>
+              <a:t>32</a:t>
             </a:fld>
             <a:endParaRPr lang="en-US"/>
           </a:p>
@@ -1548,7 +1631,7 @@
     </p:spTree>
     <p:extLst>
       <p:ext uri="{BB962C8B-B14F-4D97-AF65-F5344CB8AC3E}">
-        <p14:creationId xmlns:p14="http://schemas.microsoft.com/office/powerpoint/2010/main" val="4196810274"/>
+        <p14:creationId xmlns:p14="http://schemas.microsoft.com/office/powerpoint/2010/main" val="3911842899"/>
       </p:ext>
     </p:extLst>
   </p:cSld>
@@ -5786,7 +5869,7 @@
         </p:blipFill>
         <p:spPr>
           <a:xfrm>
-            <a:off x="43999" y="91442"/>
+            <a:off x="43999" y="95598"/>
             <a:ext cx="2653335" cy="773219"/>
           </a:xfrm>
           <a:prstGeom prst="rect">
@@ -6858,7 +6941,7 @@
         </p:nvSpPr>
         <p:spPr>
           <a:xfrm>
-            <a:off x="7162171" y="4049879"/>
+            <a:off x="6854813" y="4049879"/>
             <a:ext cx="5337187" cy="1938992"/>
           </a:xfrm>
           <a:prstGeom prst="rect">
@@ -6934,8 +7017,8 @@
           <a:chExt cx="0" cy="0"/>
         </a:xfrm>
       </p:grpSpPr>
-      <mc:AlternateContent xmlns:mc="http://schemas.openxmlformats.org/markup-compatibility/2006" xmlns:a14="http://schemas.microsoft.com/office/drawing/2010/main">
-        <mc:Choice Requires="a14">
+      <mc:AlternateContent xmlns:mc="http://schemas.openxmlformats.org/markup-compatibility/2006">
+        <mc:Choice xmlns:a14="http://schemas.microsoft.com/office/drawing/2010/main" Requires="a14">
           <p:sp>
             <p:nvSpPr>
               <p:cNvPr id="4" name="Rectangle 3">
@@ -6951,7 +7034,7 @@
             <p:spPr>
               <a:xfrm>
                 <a:off x="224378" y="3620419"/>
-                <a:ext cx="3193567" cy="707886"/>
+                <a:ext cx="3186257" cy="707886"/>
               </a:xfrm>
               <a:prstGeom prst="rect">
                 <a:avLst/>
@@ -6971,13 +7054,13 @@
                     </m:oMathParaPr>
                     <m:oMath xmlns:m="http://schemas.openxmlformats.org/officeDocument/2006/math">
                       <m:r>
-                        <a:rPr lang="en-US" sz="4000" i="1">
+                        <a:rPr lang="en-US" sz="4000" i="1" smtClean="0">
                           <a:latin typeface="Cambria Math" panose="02040503050406030204" pitchFamily="18" charset="0"/>
                         </a:rPr>
                         <m:t>∑</m:t>
                       </m:r>
                       <m:r>
-                        <a:rPr lang="en-US" sz="4000" i="1">
+                        <a:rPr lang="en-US" sz="4000" i="1" smtClean="0">
                           <a:latin typeface="Cambria Math" panose="02040503050406030204" pitchFamily="18" charset="0"/>
                         </a:rPr>
                         <m:t>𝑢</m:t>
@@ -7001,10 +7084,10 @@
                             </m:sSubPr>
                             <m:e>
                               <m:r>
-                                <a:rPr lang="en-US" sz="4000" i="1">
+                                <a:rPr lang="en-US" sz="4000" b="0" i="1" smtClean="0">
                                   <a:latin typeface="Cambria Math" panose="02040503050406030204" pitchFamily="18" charset="0"/>
                                 </a:rPr>
-                                <m:t>𝑥</m:t>
+                                <m:t>𝑦</m:t>
                               </m:r>
                             </m:e>
                             <m:sub>
@@ -7072,7 +7155,7 @@
             </p:txBody>
           </p:sp>
         </mc:Choice>
-        <mc:Fallback xmlns="">
+        <mc:Fallback>
           <p:sp>
             <p:nvSpPr>
               <p:cNvPr id="4" name="Rectangle 3">
@@ -7090,7 +7173,7 @@
             <p:spPr>
               <a:xfrm>
                 <a:off x="224378" y="3620419"/>
-                <a:ext cx="3193567" cy="707886"/>
+                <a:ext cx="3186257" cy="707886"/>
               </a:xfrm>
               <a:prstGeom prst="rect">
                 <a:avLst/>
@@ -7134,7 +7217,7 @@
             <p:spPr>
               <a:xfrm>
                 <a:off x="4467965" y="1471794"/>
-                <a:ext cx="5628336" cy="707886"/>
+                <a:ext cx="5880328" cy="707886"/>
               </a:xfrm>
               <a:prstGeom prst="rect">
                 <a:avLst/>
@@ -7178,10 +7261,10 @@
                             </m:sSubPr>
                             <m:e>
                               <m:r>
-                                <a:rPr lang="en-US" sz="4000" b="0" i="1" smtClean="0">
+                                <a:rPr lang="en-US" sz="4000" b="1" i="1" smtClean="0">
                                   <a:latin typeface="Cambria Math" panose="02040503050406030204" pitchFamily="18" charset="0"/>
                                 </a:rPr>
-                                <m:t>𝑧</m:t>
+                                <m:t>𝑿</m:t>
                               </m:r>
                             </m:e>
                             <m:sub>
@@ -7225,17 +7308,17 @@
                           <m:sSub>
                             <m:sSubPr>
                               <m:ctrlPr>
-                                <a:rPr lang="en-US" sz="4000" i="1">
+                                <a:rPr lang="en-US" sz="4000" i="1" smtClean="0">
                                   <a:latin typeface="Cambria Math" panose="02040503050406030204" pitchFamily="18" charset="0"/>
                                 </a:rPr>
                               </m:ctrlPr>
                             </m:sSubPr>
                             <m:e>
                               <m:r>
-                                <a:rPr lang="en-US" sz="4000" i="1">
+                                <a:rPr lang="en-US" sz="4000" b="0" i="1" smtClean="0">
                                   <a:latin typeface="Cambria Math" panose="02040503050406030204" pitchFamily="18" charset="0"/>
                                 </a:rPr>
-                                <m:t>𝑥</m:t>
+                                <m:t>𝑦</m:t>
                               </m:r>
                             </m:e>
                             <m:sub>
@@ -7274,10 +7357,10 @@
                         </m:sSubPr>
                         <m:e>
                           <m:r>
-                            <a:rPr lang="en-US" sz="4000" i="1">
-                              <a:latin typeface="Cambria Math" panose="02040503050406030204" pitchFamily="18" charset="0"/>
-                            </a:rPr>
-                            <m:t>𝑥</m:t>
+                            <a:rPr lang="en-US" sz="4000" b="0" i="1" smtClean="0">
+                              <a:latin typeface="Cambria Math" panose="02040503050406030204" pitchFamily="18" charset="0"/>
+                            </a:rPr>
+                            <m:t>𝑦</m:t>
                           </m:r>
                         </m:e>
                         <m:sub>
@@ -7352,7 +7435,7 @@
             <p:spPr>
               <a:xfrm>
                 <a:off x="4467965" y="1471794"/>
-                <a:ext cx="5628336" cy="707886"/>
+                <a:ext cx="5880328" cy="707886"/>
               </a:xfrm>
               <a:prstGeom prst="rect">
                 <a:avLst/>
@@ -7396,7 +7479,7 @@
             <p:spPr>
               <a:xfrm>
                 <a:off x="4391661" y="2463015"/>
-                <a:ext cx="5720477" cy="707886"/>
+                <a:ext cx="5904052" cy="707886"/>
               </a:xfrm>
               <a:prstGeom prst="rect">
                 <a:avLst/>
@@ -7440,10 +7523,10 @@
                             </m:sSubPr>
                             <m:e>
                               <m:r>
-                                <a:rPr lang="en-US" sz="4000" b="0" i="1" smtClean="0">
+                                <a:rPr lang="en-US" sz="4000" b="1" i="1" smtClean="0">
                                   <a:latin typeface="Cambria Math" panose="02040503050406030204" pitchFamily="18" charset="0"/>
                                 </a:rPr>
-                                <m:t>𝑧</m:t>
+                                <m:t>𝑿</m:t>
                               </m:r>
                             </m:e>
                             <m:sub>
@@ -7494,10 +7577,10 @@
                             </m:sSubPr>
                             <m:e>
                               <m:r>
-                                <a:rPr lang="en-US" sz="4000" i="1">
+                                <a:rPr lang="en-US" sz="4000" b="0" i="1" smtClean="0">
                                   <a:latin typeface="Cambria Math" panose="02040503050406030204" pitchFamily="18" charset="0"/>
                                 </a:rPr>
-                                <m:t>𝑥</m:t>
+                                <m:t>𝑦</m:t>
                               </m:r>
                             </m:e>
                             <m:sub>
@@ -7536,10 +7619,10 @@
                         </m:sSubPr>
                         <m:e>
                           <m:r>
-                            <a:rPr lang="en-US" sz="4000" i="1">
-                              <a:latin typeface="Cambria Math" panose="02040503050406030204" pitchFamily="18" charset="0"/>
-                            </a:rPr>
-                            <m:t>𝑥</m:t>
+                            <a:rPr lang="en-US" sz="4000" b="0" i="1" smtClean="0">
+                              <a:latin typeface="Cambria Math" panose="02040503050406030204" pitchFamily="18" charset="0"/>
+                            </a:rPr>
+                            <m:t>𝑦</m:t>
                           </m:r>
                         </m:e>
                         <m:sub>
@@ -7614,7 +7697,7 @@
             <p:spPr>
               <a:xfrm>
                 <a:off x="4391661" y="2463015"/>
-                <a:ext cx="5720477" cy="707886"/>
+                <a:ext cx="5904052" cy="707886"/>
               </a:xfrm>
               <a:prstGeom prst="rect">
                 <a:avLst/>
@@ -7658,7 +7741,7 @@
             <p:spPr>
               <a:xfrm>
                 <a:off x="4391660" y="3534108"/>
-                <a:ext cx="5720477" cy="707886"/>
+                <a:ext cx="5904052" cy="707886"/>
               </a:xfrm>
               <a:prstGeom prst="rect">
                 <a:avLst/>
@@ -7702,10 +7785,10 @@
                             </m:sSubPr>
                             <m:e>
                               <m:r>
-                                <a:rPr lang="en-US" sz="4000" b="0" i="1" smtClean="0">
+                                <a:rPr lang="en-US" sz="4000" b="1" i="1" smtClean="0">
                                   <a:latin typeface="Cambria Math" panose="02040503050406030204" pitchFamily="18" charset="0"/>
                                 </a:rPr>
-                                <m:t>𝑧</m:t>
+                                <m:t>𝑿</m:t>
                               </m:r>
                             </m:e>
                             <m:sub>
@@ -7756,10 +7839,10 @@
                             </m:sSubPr>
                             <m:e>
                               <m:r>
-                                <a:rPr lang="en-US" sz="4000" i="1">
+                                <a:rPr lang="en-US" sz="4000" b="0" i="1" smtClean="0">
                                   <a:latin typeface="Cambria Math" panose="02040503050406030204" pitchFamily="18" charset="0"/>
                                 </a:rPr>
-                                <m:t>𝑥</m:t>
+                                <m:t>𝑦</m:t>
                               </m:r>
                             </m:e>
                             <m:sub>
@@ -7798,10 +7881,10 @@
                         </m:sSubPr>
                         <m:e>
                           <m:r>
-                            <a:rPr lang="en-US" sz="4000" i="1">
-                              <a:latin typeface="Cambria Math" panose="02040503050406030204" pitchFamily="18" charset="0"/>
-                            </a:rPr>
-                            <m:t>𝑥</m:t>
+                            <a:rPr lang="en-US" sz="4000" b="0" i="1" smtClean="0">
+                              <a:latin typeface="Cambria Math" panose="02040503050406030204" pitchFamily="18" charset="0"/>
+                            </a:rPr>
+                            <m:t>𝑦</m:t>
                           </m:r>
                         </m:e>
                         <m:sub>
@@ -7876,7 +7959,7 @@
             <p:spPr>
               <a:xfrm>
                 <a:off x="4391660" y="3534108"/>
-                <a:ext cx="5720477" cy="707886"/>
+                <a:ext cx="5904052" cy="707886"/>
               </a:xfrm>
               <a:prstGeom prst="rect">
                 <a:avLst/>
@@ -7920,7 +8003,7 @@
             <p:spPr>
               <a:xfrm>
                 <a:off x="4359464" y="4693206"/>
-                <a:ext cx="5815695" cy="707886"/>
+                <a:ext cx="5904052" cy="707886"/>
               </a:xfrm>
               <a:prstGeom prst="rect">
                 <a:avLst/>
@@ -7964,10 +8047,10 @@
                             </m:sSubPr>
                             <m:e>
                               <m:r>
-                                <a:rPr lang="en-US" sz="4000" b="0" i="1" smtClean="0">
+                                <a:rPr lang="en-US" sz="4000" b="1" i="1" smtClean="0">
                                   <a:latin typeface="Cambria Math" panose="02040503050406030204" pitchFamily="18" charset="0"/>
                                 </a:rPr>
-                                <m:t>𝑧</m:t>
+                                <m:t>𝑿</m:t>
                               </m:r>
                             </m:e>
                             <m:sub>
@@ -8018,10 +8101,10 @@
                             </m:sSubPr>
                             <m:e>
                               <m:r>
-                                <a:rPr lang="en-US" sz="4000" i="1">
+                                <a:rPr lang="en-US" sz="4000" b="0" i="1" smtClean="0">
                                   <a:latin typeface="Cambria Math" panose="02040503050406030204" pitchFamily="18" charset="0"/>
                                 </a:rPr>
-                                <m:t>𝑥</m:t>
+                                <m:t>𝑦</m:t>
                               </m:r>
                             </m:e>
                             <m:sub>
@@ -8060,10 +8143,10 @@
                         </m:sSubPr>
                         <m:e>
                           <m:r>
-                            <a:rPr lang="en-US" sz="4000" i="1">
-                              <a:latin typeface="Cambria Math" panose="02040503050406030204" pitchFamily="18" charset="0"/>
-                            </a:rPr>
-                            <m:t>𝑥</m:t>
+                            <a:rPr lang="en-US" sz="4000" b="0" i="1" smtClean="0">
+                              <a:latin typeface="Cambria Math" panose="02040503050406030204" pitchFamily="18" charset="0"/>
+                            </a:rPr>
+                            <m:t>𝑦</m:t>
                           </m:r>
                         </m:e>
                         <m:sub>
@@ -8138,7 +8221,7 @@
             <p:spPr>
               <a:xfrm>
                 <a:off x="4359464" y="4693206"/>
-                <a:ext cx="5815695" cy="707886"/>
+                <a:ext cx="5904052" cy="707886"/>
               </a:xfrm>
               <a:prstGeom prst="rect">
                 <a:avLst/>
@@ -8310,8 +8393,8 @@
         </p:nvCxnSpPr>
         <p:spPr>
           <a:xfrm rot="16200000" flipV="1">
-            <a:off x="10127262" y="1794776"/>
-            <a:ext cx="1122472" cy="1184393"/>
+            <a:off x="10253258" y="1920772"/>
+            <a:ext cx="1122472" cy="932401"/>
           </a:xfrm>
           <a:prstGeom prst="bentConnector2">
             <a:avLst/>
@@ -8352,8 +8435,8 @@
         </p:nvCxnSpPr>
         <p:spPr>
           <a:xfrm rot="5400000">
-            <a:off x="10093956" y="3860410"/>
-            <a:ext cx="1267943" cy="1105535"/>
+            <a:off x="10138134" y="3904588"/>
+            <a:ext cx="1267943" cy="1017178"/>
           </a:xfrm>
           <a:prstGeom prst="bentConnector2">
             <a:avLst/>
@@ -8394,8 +8477,8 @@
         </p:nvCxnSpPr>
         <p:spPr>
           <a:xfrm rot="10800000">
-            <a:off x="10112139" y="2816958"/>
-            <a:ext cx="389977" cy="546750"/>
+            <a:off x="10295713" y="2816958"/>
+            <a:ext cx="206402" cy="546750"/>
           </a:xfrm>
           <a:prstGeom prst="bentConnector3">
             <a:avLst/>
@@ -8436,8 +8519,8 @@
         </p:nvCxnSpPr>
         <p:spPr>
           <a:xfrm rot="10800000" flipV="1">
-            <a:off x="10112137" y="3363707"/>
-            <a:ext cx="389978" cy="524343"/>
+            <a:off x="10295713" y="3363707"/>
+            <a:ext cx="206403" cy="524343"/>
           </a:xfrm>
           <a:prstGeom prst="bentConnector3">
             <a:avLst/>
@@ -17447,6 +17530,1703 @@
           <a:chExt cx="0" cy="0"/>
         </a:xfrm>
       </p:grpSpPr>
+      <p:pic>
+        <p:nvPicPr>
+          <p:cNvPr id="2050" name="Picture 2" descr="National Institute of Allergy and Infectious Diseases (NIAID)">
+            <a:extLst>
+              <a:ext uri="{FF2B5EF4-FFF2-40B4-BE49-F238E27FC236}">
+                <a16:creationId xmlns:a16="http://schemas.microsoft.com/office/drawing/2014/main" id="{2BC84C55-C217-34E3-8730-BDD60140122C}"/>
+              </a:ext>
+            </a:extLst>
+          </p:cNvPr>
+          <p:cNvPicPr>
+            <a:picLocks noChangeAspect="1" noChangeArrowheads="1"/>
+          </p:cNvPicPr>
+          <p:nvPr/>
+        </p:nvPicPr>
+        <p:blipFill>
+          <a:blip r:embed="rId3">
+            <a:extLst>
+              <a:ext uri="{28A0092B-C50C-407E-A947-70E740481C1C}">
+                <a14:useLocalDpi xmlns:a14="http://schemas.microsoft.com/office/drawing/2010/main" val="0"/>
+              </a:ext>
+            </a:extLst>
+          </a:blip>
+          <a:srcRect/>
+          <a:stretch>
+            <a:fillRect/>
+          </a:stretch>
+        </p:blipFill>
+        <p:spPr bwMode="auto">
+          <a:xfrm>
+            <a:off x="427403" y="1235453"/>
+            <a:ext cx="2933700" cy="1571625"/>
+          </a:xfrm>
+          <a:prstGeom prst="rect">
+            <a:avLst/>
+          </a:prstGeom>
+          <a:noFill/>
+          <a:extLst>
+            <a:ext uri="{909E8E84-426E-40DD-AFC4-6F175D3DCCD1}">
+              <a14:hiddenFill xmlns:a14="http://schemas.microsoft.com/office/drawing/2010/main">
+                <a:solidFill>
+                  <a:srgbClr val="FFFFFF"/>
+                </a:solidFill>
+              </a14:hiddenFill>
+            </a:ext>
+          </a:extLst>
+        </p:spPr>
+      </p:pic>
+      <p:sp>
+        <p:nvSpPr>
+          <p:cNvPr id="11" name="Rectangle 10">
+            <a:extLst>
+              <a:ext uri="{FF2B5EF4-FFF2-40B4-BE49-F238E27FC236}">
+                <a16:creationId xmlns:a16="http://schemas.microsoft.com/office/drawing/2014/main" id="{24B8B7D4-03B5-91FF-120A-A2C3068CBB0A}"/>
+              </a:ext>
+            </a:extLst>
+          </p:cNvPr>
+          <p:cNvSpPr/>
+          <p:nvPr/>
+        </p:nvSpPr>
+        <p:spPr>
+          <a:xfrm>
+            <a:off x="648237" y="2412642"/>
+            <a:ext cx="2667000" cy="768440"/>
+          </a:xfrm>
+          <a:prstGeom prst="rect">
+            <a:avLst/>
+          </a:prstGeom>
+          <a:solidFill>
+            <a:schemeClr val="bg2">
+              <a:lumMod val="50000"/>
+            </a:schemeClr>
+          </a:solidFill>
+        </p:spPr>
+        <p:style>
+          <a:lnRef idx="2">
+            <a:schemeClr val="accent1">
+              <a:shade val="15000"/>
+            </a:schemeClr>
+          </a:lnRef>
+          <a:fillRef idx="1">
+            <a:schemeClr val="accent1"/>
+          </a:fillRef>
+          <a:effectRef idx="0">
+            <a:schemeClr val="accent1"/>
+          </a:effectRef>
+          <a:fontRef idx="minor">
+            <a:schemeClr val="lt1"/>
+          </a:fontRef>
+        </p:style>
+        <p:txBody>
+          <a:bodyPr rtlCol="0" anchor="ctr"/>
+          <a:lstStyle/>
+          <a:p>
+            <a:pPr algn="ctr"/>
+            <a:endParaRPr lang="en-US"/>
+          </a:p>
+        </p:txBody>
+      </p:sp>
+      <p:sp>
+        <p:nvSpPr>
+          <p:cNvPr id="8" name="TextBox 7">
+            <a:extLst>
+              <a:ext uri="{FF2B5EF4-FFF2-40B4-BE49-F238E27FC236}">
+                <a16:creationId xmlns:a16="http://schemas.microsoft.com/office/drawing/2014/main" id="{D43A2506-C608-A0F0-5A4C-46D4F462CFD1}"/>
+              </a:ext>
+            </a:extLst>
+          </p:cNvPr>
+          <p:cNvSpPr txBox="1"/>
+          <p:nvPr/>
+        </p:nvSpPr>
+        <p:spPr>
+          <a:xfrm>
+            <a:off x="448041" y="241247"/>
+            <a:ext cx="3606800" cy="923330"/>
+          </a:xfrm>
+          <a:prstGeom prst="rect">
+            <a:avLst/>
+          </a:prstGeom>
+          <a:noFill/>
+        </p:spPr>
+        <p:txBody>
+          <a:bodyPr wrap="square" rtlCol="0">
+            <a:spAutoFit/>
+          </a:bodyPr>
+          <a:lstStyle/>
+          <a:p>
+            <a:r>
+              <a:rPr lang="en-US" sz="5400" b="1" dirty="0">
+                <a:latin typeface="Source Sans Pro" panose="020B0503030403020204" pitchFamily="34" charset="0"/>
+                <a:ea typeface="Source Sans Pro" panose="020B0503030403020204" pitchFamily="34" charset="0"/>
+              </a:rPr>
+              <a:t>Thank you!</a:t>
+            </a:r>
+          </a:p>
+        </p:txBody>
+      </p:sp>
+      <p:sp>
+        <p:nvSpPr>
+          <p:cNvPr id="13" name="Rectangle 12">
+            <a:extLst>
+              <a:ext uri="{FF2B5EF4-FFF2-40B4-BE49-F238E27FC236}">
+                <a16:creationId xmlns:a16="http://schemas.microsoft.com/office/drawing/2014/main" id="{6CF1CDF5-E07C-7132-490B-2F7F47BD15A4}"/>
+              </a:ext>
+            </a:extLst>
+          </p:cNvPr>
+          <p:cNvSpPr/>
+          <p:nvPr/>
+        </p:nvSpPr>
+        <p:spPr>
+          <a:xfrm>
+            <a:off x="4680033" y="977550"/>
+            <a:ext cx="7397365" cy="5816977"/>
+          </a:xfrm>
+          <a:prstGeom prst="rect">
+            <a:avLst/>
+          </a:prstGeom>
+        </p:spPr>
+        <p:txBody>
+          <a:bodyPr wrap="square">
+            <a:spAutoFit/>
+          </a:bodyPr>
+          <a:lstStyle/>
+          <a:p>
+            <a:r>
+              <a:rPr lang="en-US" sz="1400" b="1" dirty="0">
+                <a:solidFill>
+                  <a:srgbClr val="1FAEDB"/>
+                </a:solidFill>
+                <a:latin typeface="Source Sans Pro SemiBold" panose="020B0503030403020204" pitchFamily="34" charset="0"/>
+                <a:ea typeface="Source Sans Pro SemiBold" panose="020B0503030403020204" pitchFamily="34" charset="0"/>
+                <a:cs typeface="Arial Unicode MS" panose="020B0604020202020204" pitchFamily="34" charset="-128"/>
+              </a:rPr>
+              <a:t>Coordination Team</a:t>
+            </a:r>
+            <a:br>
+              <a:rPr lang="en-US" sz="1400" b="1" dirty="0">
+                <a:solidFill>
+                  <a:srgbClr val="1FAEDB"/>
+                </a:solidFill>
+                <a:latin typeface="Garamond" panose="02020404030301010803" pitchFamily="18" charset="0"/>
+                <a:ea typeface="Arial Unicode MS" panose="020B0604020202020204" pitchFamily="34" charset="-128"/>
+                <a:cs typeface="Arial Unicode MS" panose="020B0604020202020204" pitchFamily="34" charset="-128"/>
+              </a:rPr>
+            </a:br>
+            <a:r>
+              <a:rPr lang="en-US" altLang="en-US" sz="1100" dirty="0" err="1">
+                <a:latin typeface="Source Sans Pro" panose="020B0503030403020204" pitchFamily="34" charset="0"/>
+                <a:ea typeface="Source Sans Pro" panose="020B0503030403020204" pitchFamily="34" charset="0"/>
+                <a:cs typeface="Times New Roman" panose="02020603050405020304" pitchFamily="18" charset="0"/>
+              </a:rPr>
+              <a:t>Katriona</a:t>
+            </a:r>
+            <a:r>
+              <a:rPr lang="en-US" altLang="en-US" sz="1100" dirty="0">
+                <a:latin typeface="Source Sans Pro" panose="020B0503030403020204" pitchFamily="34" charset="0"/>
+                <a:ea typeface="Source Sans Pro" panose="020B0503030403020204" pitchFamily="34" charset="0"/>
+                <a:cs typeface="Times New Roman" panose="02020603050405020304" pitchFamily="18" charset="0"/>
+              </a:rPr>
+              <a:t> Shea, Justin Lessler, </a:t>
+            </a:r>
+            <a:r>
+              <a:rPr lang="en-US" sz="1100" dirty="0">
+                <a:latin typeface="Source Sans Pro" panose="020B0503030403020204" pitchFamily="34" charset="0"/>
+                <a:ea typeface="Source Sans Pro" panose="020B0503030403020204" pitchFamily="34" charset="0"/>
+              </a:rPr>
+              <a:t>Cécile Viboud, </a:t>
+            </a:r>
+            <a:r>
+              <a:rPr lang="en-US" altLang="en-US" sz="1100" dirty="0">
+                <a:latin typeface="Source Sans Pro" panose="020B0503030403020204" pitchFamily="34" charset="0"/>
+                <a:ea typeface="Source Sans Pro" panose="020B0503030403020204" pitchFamily="34" charset="0"/>
+                <a:cs typeface="Times New Roman" panose="02020603050405020304" pitchFamily="18" charset="0"/>
+              </a:rPr>
+              <a:t>Rebecca Borchering, Emily Howerton, Shaun Truelove, Claire Smith, Michelle Qin, Nicholas Reich, Michael Runge, Lucie Contamin, John Levander, Jessica Kerr, Harry Hochheiser, Luke Mullany, Sara Loo, Sung-</a:t>
+            </a:r>
+            <a:r>
+              <a:rPr lang="en-US" altLang="en-US" sz="1100" dirty="0" err="1">
+                <a:latin typeface="Source Sans Pro" panose="020B0503030403020204" pitchFamily="34" charset="0"/>
+                <a:ea typeface="Source Sans Pro" panose="020B0503030403020204" pitchFamily="34" charset="0"/>
+                <a:cs typeface="Times New Roman" panose="02020603050405020304" pitchFamily="18" charset="0"/>
+              </a:rPr>
+              <a:t>mok</a:t>
+            </a:r>
+            <a:r>
+              <a:rPr lang="en-US" altLang="en-US" sz="1100" dirty="0">
+                <a:latin typeface="Source Sans Pro" panose="020B0503030403020204" pitchFamily="34" charset="0"/>
+                <a:ea typeface="Source Sans Pro" panose="020B0503030403020204" pitchFamily="34" charset="0"/>
+                <a:cs typeface="Times New Roman" panose="02020603050405020304" pitchFamily="18" charset="0"/>
+              </a:rPr>
+              <a:t> Jung, </a:t>
+            </a:r>
+            <a:r>
+              <a:rPr lang="en-US" altLang="en-US" sz="1100" dirty="0" err="1">
+                <a:latin typeface="Source Sans Pro" panose="020B0503030403020204" pitchFamily="34" charset="0"/>
+                <a:ea typeface="Source Sans Pro" panose="020B0503030403020204" pitchFamily="34" charset="0"/>
+                <a:cs typeface="Times New Roman" panose="02020603050405020304" pitchFamily="18" charset="0"/>
+              </a:rPr>
+              <a:t>Smantha</a:t>
+            </a:r>
+            <a:r>
+              <a:rPr lang="en-US" altLang="en-US" sz="1100" dirty="0">
+                <a:latin typeface="Source Sans Pro" panose="020B0503030403020204" pitchFamily="34" charset="0"/>
+                <a:ea typeface="Source Sans Pro" panose="020B0503030403020204" pitchFamily="34" charset="0"/>
+                <a:cs typeface="Times New Roman" panose="02020603050405020304" pitchFamily="18" charset="0"/>
+              </a:rPr>
+              <a:t> Bents, Katie Yan</a:t>
+            </a:r>
+          </a:p>
+          <a:p>
+            <a:endParaRPr lang="en-US" sz="1100" b="1" dirty="0">
+              <a:solidFill>
+                <a:srgbClr val="00B050"/>
+              </a:solidFill>
+              <a:latin typeface="Source Sans Pro SemiBold" panose="020B0503030403020204" pitchFamily="34" charset="0"/>
+              <a:ea typeface="Source Sans Pro SemiBold" panose="020B0503030403020204" pitchFamily="34" charset="0"/>
+              <a:cs typeface="Arial Unicode MS" panose="020B0604020202020204" pitchFamily="34" charset="-128"/>
+            </a:endParaRPr>
+          </a:p>
+          <a:p>
+            <a:r>
+              <a:rPr lang="en-US" sz="1400" b="1" dirty="0">
+                <a:solidFill>
+                  <a:srgbClr val="1FAEDB"/>
+                </a:solidFill>
+                <a:latin typeface="Source Sans Pro SemiBold" panose="020B0503030403020204" pitchFamily="34" charset="0"/>
+                <a:ea typeface="Source Sans Pro SemiBold" panose="020B0503030403020204" pitchFamily="34" charset="0"/>
+                <a:cs typeface="Arial Unicode MS" panose="020B0604020202020204" pitchFamily="34" charset="-128"/>
+              </a:rPr>
+              <a:t>Modeling Groups Contributing COVID-19 Projections</a:t>
+            </a:r>
+            <a:endParaRPr lang="en-US" sz="1400" dirty="0">
+              <a:solidFill>
+                <a:srgbClr val="1FAEDB"/>
+              </a:solidFill>
+              <a:latin typeface="Source Sans Pro" panose="020B0503030403020204" pitchFamily="34" charset="0"/>
+              <a:ea typeface="Source Sans Pro" panose="020B0503030403020204" pitchFamily="34" charset="0"/>
+            </a:endParaRPr>
+          </a:p>
+          <a:p>
+            <a:r>
+              <a:rPr lang="en-US" sz="1100" i="1" dirty="0">
+                <a:latin typeface="Source Sans Pro" panose="020B0503030403020204" pitchFamily="34" charset="0"/>
+                <a:ea typeface="Source Sans Pro" panose="020B0503030403020204" pitchFamily="34" charset="0"/>
+              </a:rPr>
+              <a:t>Columbia University </a:t>
+            </a:r>
+            <a:r>
+              <a:rPr lang="en-US" sz="1100" dirty="0">
+                <a:latin typeface="Source Sans Pro" panose="020B0503030403020204" pitchFamily="34" charset="0"/>
+                <a:ea typeface="Source Sans Pro" panose="020B0503030403020204" pitchFamily="34" charset="0"/>
+              </a:rPr>
+              <a:t>– Age-Stratified Model: Marta </a:t>
+            </a:r>
+            <a:r>
+              <a:rPr lang="en-US" sz="1100" dirty="0" err="1">
+                <a:latin typeface="Source Sans Pro" panose="020B0503030403020204" pitchFamily="34" charset="0"/>
+                <a:ea typeface="Source Sans Pro" panose="020B0503030403020204" pitchFamily="34" charset="0"/>
+              </a:rPr>
+              <a:t>Galanti</a:t>
+            </a:r>
+            <a:r>
+              <a:rPr lang="en-US" sz="1100" dirty="0">
+                <a:latin typeface="Source Sans Pro" panose="020B0503030403020204" pitchFamily="34" charset="0"/>
+                <a:ea typeface="Source Sans Pro" panose="020B0503030403020204" pitchFamily="34" charset="0"/>
+              </a:rPr>
+              <a:t>, Teresa </a:t>
+            </a:r>
+            <a:r>
+              <a:rPr lang="en-US" sz="1100" dirty="0" err="1">
+                <a:latin typeface="Source Sans Pro" panose="020B0503030403020204" pitchFamily="34" charset="0"/>
+                <a:ea typeface="Source Sans Pro" panose="020B0503030403020204" pitchFamily="34" charset="0"/>
+              </a:rPr>
+              <a:t>Yamana</a:t>
+            </a:r>
+            <a:r>
+              <a:rPr lang="en-US" sz="1100" dirty="0">
+                <a:latin typeface="Source Sans Pro" panose="020B0503030403020204" pitchFamily="34" charset="0"/>
+                <a:ea typeface="Source Sans Pro" panose="020B0503030403020204" pitchFamily="34" charset="0"/>
+              </a:rPr>
+              <a:t>, Sen Pei, Jeffrey Shaman</a:t>
+            </a:r>
+          </a:p>
+          <a:p>
+            <a:r>
+              <a:rPr lang="en-US" sz="1100" i="1" dirty="0">
+                <a:latin typeface="Source Sans Pro" panose="020B0503030403020204" pitchFamily="34" charset="0"/>
+                <a:ea typeface="Source Sans Pro" panose="020B0503030403020204" pitchFamily="34" charset="0"/>
+              </a:rPr>
+              <a:t>Institute for Health Metrics and Evaluation – IHME COVID</a:t>
+            </a:r>
+          </a:p>
+          <a:p>
+            <a:r>
+              <a:rPr lang="en-US" sz="1100" i="1" dirty="0">
+                <a:latin typeface="Source Sans Pro" panose="020B0503030403020204" pitchFamily="34" charset="0"/>
+                <a:ea typeface="Source Sans Pro" panose="020B0503030403020204" pitchFamily="34" charset="0"/>
+              </a:rPr>
+              <a:t>John Hopkins University-APL</a:t>
+            </a:r>
+            <a:r>
+              <a:rPr lang="en-US" sz="1100" dirty="0">
+                <a:latin typeface="Source Sans Pro" panose="020B0503030403020204" pitchFamily="34" charset="0"/>
+                <a:ea typeface="Source Sans Pro" panose="020B0503030403020204" pitchFamily="34" charset="0"/>
+              </a:rPr>
+              <a:t>: Matt Kinsey, Kate </a:t>
+            </a:r>
+            <a:r>
+              <a:rPr lang="en-US" sz="1100" dirty="0" err="1">
+                <a:latin typeface="Source Sans Pro" panose="020B0503030403020204" pitchFamily="34" charset="0"/>
+                <a:ea typeface="Source Sans Pro" panose="020B0503030403020204" pitchFamily="34" charset="0"/>
+              </a:rPr>
+              <a:t>Tallaksen</a:t>
+            </a:r>
+            <a:r>
+              <a:rPr lang="en-US" sz="1100" dirty="0">
+                <a:latin typeface="Source Sans Pro" panose="020B0503030403020204" pitchFamily="34" charset="0"/>
+                <a:ea typeface="Source Sans Pro" panose="020B0503030403020204" pitchFamily="34" charset="0"/>
+              </a:rPr>
+              <a:t>, R.F. </a:t>
+            </a:r>
+            <a:r>
+              <a:rPr lang="en-US" sz="1100" dirty="0" err="1">
+                <a:latin typeface="Source Sans Pro" panose="020B0503030403020204" pitchFamily="34" charset="0"/>
+                <a:ea typeface="Source Sans Pro" panose="020B0503030403020204" pitchFamily="34" charset="0"/>
+              </a:rPr>
+              <a:t>Obrecht</a:t>
+            </a:r>
+            <a:r>
+              <a:rPr lang="en-US" sz="1100" dirty="0">
+                <a:latin typeface="Source Sans Pro" panose="020B0503030403020204" pitchFamily="34" charset="0"/>
+                <a:ea typeface="Source Sans Pro" panose="020B0503030403020204" pitchFamily="34" charset="0"/>
+              </a:rPr>
+              <a:t>, Laura Asher, Cash Costello, Michael </a:t>
+            </a:r>
+            <a:r>
+              <a:rPr lang="en-US" sz="1100" dirty="0" err="1">
+                <a:latin typeface="Source Sans Pro" panose="020B0503030403020204" pitchFamily="34" charset="0"/>
+                <a:ea typeface="Source Sans Pro" panose="020B0503030403020204" pitchFamily="34" charset="0"/>
+              </a:rPr>
+              <a:t>Kelbaugh</a:t>
+            </a:r>
+            <a:r>
+              <a:rPr lang="en-US" sz="1100" dirty="0">
+                <a:latin typeface="Source Sans Pro" panose="020B0503030403020204" pitchFamily="34" charset="0"/>
+                <a:ea typeface="Source Sans Pro" panose="020B0503030403020204" pitchFamily="34" charset="0"/>
+              </a:rPr>
+              <a:t>, Shelby Wilson, Kaitlin Lovett</a:t>
+            </a:r>
+          </a:p>
+          <a:p>
+            <a:r>
+              <a:rPr lang="en-US" sz="1100" i="1" dirty="0">
+                <a:latin typeface="Source Sans Pro" panose="020B0503030403020204" pitchFamily="34" charset="0"/>
+                <a:ea typeface="Source Sans Pro" panose="020B0503030403020204" pitchFamily="34" charset="0"/>
+              </a:rPr>
+              <a:t>John Hopkins University-IDD-COVIDSP</a:t>
+            </a:r>
+            <a:r>
+              <a:rPr lang="en-US" sz="1100" dirty="0">
+                <a:latin typeface="Source Sans Pro" panose="020B0503030403020204" pitchFamily="34" charset="0"/>
+                <a:ea typeface="Source Sans Pro" panose="020B0503030403020204" pitchFamily="34" charset="0"/>
+              </a:rPr>
+              <a:t>: Joseph C. Lemaitre, Juan Dent Hulse,  Kyra H. </a:t>
+            </a:r>
+            <a:r>
+              <a:rPr lang="en-US" sz="1100" dirty="0" err="1">
+                <a:latin typeface="Source Sans Pro" panose="020B0503030403020204" pitchFamily="34" charset="0"/>
+                <a:ea typeface="Source Sans Pro" panose="020B0503030403020204" pitchFamily="34" charset="0"/>
+              </a:rPr>
+              <a:t>Grantz</a:t>
+            </a:r>
+            <a:r>
+              <a:rPr lang="en-US" sz="1100" dirty="0">
+                <a:latin typeface="Source Sans Pro" panose="020B0503030403020204" pitchFamily="34" charset="0"/>
+                <a:ea typeface="Source Sans Pro" panose="020B0503030403020204" pitchFamily="34" charset="0"/>
+              </a:rPr>
+              <a:t>, Joshua Kaminsky, </a:t>
+            </a:r>
+            <a:br>
+              <a:rPr lang="en-US" sz="1100" dirty="0">
+                <a:latin typeface="Source Sans Pro" panose="020B0503030403020204" pitchFamily="34" charset="0"/>
+                <a:ea typeface="Source Sans Pro" panose="020B0503030403020204" pitchFamily="34" charset="0"/>
+              </a:rPr>
+            </a:br>
+            <a:r>
+              <a:rPr lang="en-US" sz="1100" dirty="0">
+                <a:latin typeface="Source Sans Pro" panose="020B0503030403020204" pitchFamily="34" charset="0"/>
+                <a:ea typeface="Source Sans Pro" panose="020B0503030403020204" pitchFamily="34" charset="0"/>
+              </a:rPr>
+              <a:t>Stephen A. Lauer, Elizabeth C. Lee, Justin Lessler, Hannah R. Meredith, Javier Perez-</a:t>
+            </a:r>
+            <a:r>
+              <a:rPr lang="en-US" sz="1100" dirty="0" err="1">
+                <a:latin typeface="Source Sans Pro" panose="020B0503030403020204" pitchFamily="34" charset="0"/>
+                <a:ea typeface="Source Sans Pro" panose="020B0503030403020204" pitchFamily="34" charset="0"/>
+              </a:rPr>
+              <a:t>Saez</a:t>
+            </a:r>
+            <a:r>
+              <a:rPr lang="en-US" sz="1100" dirty="0">
+                <a:latin typeface="Source Sans Pro" panose="020B0503030403020204" pitchFamily="34" charset="0"/>
+                <a:ea typeface="Source Sans Pro" panose="020B0503030403020204" pitchFamily="34" charset="0"/>
+              </a:rPr>
+              <a:t>, Shaun A. Truelove, Claire P. Smith, Lindsay T. Keegan, Kathryn Kaminsky, Sam Shah, Josh Wills, Pierre-Yves </a:t>
+            </a:r>
+            <a:r>
+              <a:rPr lang="en-US" sz="1100" dirty="0" err="1">
+                <a:latin typeface="Source Sans Pro" panose="020B0503030403020204" pitchFamily="34" charset="0"/>
+                <a:ea typeface="Source Sans Pro" panose="020B0503030403020204" pitchFamily="34" charset="0"/>
+              </a:rPr>
+              <a:t>Aquilanti</a:t>
+            </a:r>
+            <a:r>
+              <a:rPr lang="en-US" sz="1100" dirty="0">
+                <a:latin typeface="Source Sans Pro" panose="020B0503030403020204" pitchFamily="34" charset="0"/>
+                <a:ea typeface="Source Sans Pro" panose="020B0503030403020204" pitchFamily="34" charset="0"/>
+              </a:rPr>
+              <a:t>, Karthik Raman,  </a:t>
+            </a:r>
+            <a:br>
+              <a:rPr lang="en-US" sz="1100" dirty="0">
+                <a:latin typeface="Source Sans Pro" panose="020B0503030403020204" pitchFamily="34" charset="0"/>
+                <a:ea typeface="Source Sans Pro" panose="020B0503030403020204" pitchFamily="34" charset="0"/>
+              </a:rPr>
+            </a:br>
+            <a:r>
+              <a:rPr lang="en-US" sz="1100" dirty="0">
+                <a:latin typeface="Source Sans Pro" panose="020B0503030403020204" pitchFamily="34" charset="0"/>
+                <a:ea typeface="Source Sans Pro" panose="020B0503030403020204" pitchFamily="34" charset="0"/>
+              </a:rPr>
+              <a:t>Arun </a:t>
+            </a:r>
+            <a:r>
+              <a:rPr lang="en-US" sz="1100" dirty="0" err="1">
+                <a:latin typeface="Source Sans Pro" panose="020B0503030403020204" pitchFamily="34" charset="0"/>
+                <a:ea typeface="Source Sans Pro" panose="020B0503030403020204" pitchFamily="34" charset="0"/>
+              </a:rPr>
+              <a:t>Subramaniyan</a:t>
+            </a:r>
+            <a:r>
+              <a:rPr lang="en-US" sz="1100" dirty="0">
+                <a:latin typeface="Source Sans Pro" panose="020B0503030403020204" pitchFamily="34" charset="0"/>
+                <a:ea typeface="Source Sans Pro" panose="020B0503030403020204" pitchFamily="34" charset="0"/>
+              </a:rPr>
+              <a:t>, Greg </a:t>
+            </a:r>
+            <a:r>
+              <a:rPr lang="en-US" sz="1100" dirty="0" err="1">
+                <a:latin typeface="Source Sans Pro" panose="020B0503030403020204" pitchFamily="34" charset="0"/>
+                <a:ea typeface="Source Sans Pro" panose="020B0503030403020204" pitchFamily="34" charset="0"/>
+              </a:rPr>
+              <a:t>Thursam</a:t>
+            </a:r>
+            <a:r>
+              <a:rPr lang="en-US" sz="1100" dirty="0">
+                <a:latin typeface="Source Sans Pro" panose="020B0503030403020204" pitchFamily="34" charset="0"/>
+                <a:ea typeface="Source Sans Pro" panose="020B0503030403020204" pitchFamily="34" charset="0"/>
+              </a:rPr>
+              <a:t>, Anh Tran</a:t>
+            </a:r>
+          </a:p>
+          <a:p>
+            <a:r>
+              <a:rPr lang="en-US" sz="1100" i="1" dirty="0">
+                <a:latin typeface="Source Sans Pro" panose="020B0503030403020204" pitchFamily="34" charset="0"/>
+                <a:ea typeface="Source Sans Pro" panose="020B0503030403020204" pitchFamily="34" charset="0"/>
+              </a:rPr>
+              <a:t>North Carolina State University-COVSIM</a:t>
+            </a:r>
+            <a:r>
+              <a:rPr lang="en-US" sz="1100" dirty="0">
+                <a:latin typeface="Source Sans Pro" panose="020B0503030403020204" pitchFamily="34" charset="0"/>
+                <a:ea typeface="Source Sans Pro" panose="020B0503030403020204" pitchFamily="34" charset="0"/>
+              </a:rPr>
+              <a:t>: Erik </a:t>
+            </a:r>
+            <a:r>
+              <a:rPr lang="en-US" sz="1100" dirty="0" err="1">
+                <a:latin typeface="Source Sans Pro" panose="020B0503030403020204" pitchFamily="34" charset="0"/>
+                <a:ea typeface="Source Sans Pro" panose="020B0503030403020204" pitchFamily="34" charset="0"/>
+              </a:rPr>
+              <a:t>Rosenstrom</a:t>
+            </a:r>
+            <a:r>
+              <a:rPr lang="en-US" sz="1100" dirty="0">
+                <a:latin typeface="Source Sans Pro" panose="020B0503030403020204" pitchFamily="34" charset="0"/>
+                <a:ea typeface="Source Sans Pro" panose="020B0503030403020204" pitchFamily="34" charset="0"/>
+              </a:rPr>
+              <a:t>, Jessica Mele, Julie Swann, Julie Ivy, Maria Mayorga</a:t>
+            </a:r>
+          </a:p>
+          <a:p>
+            <a:r>
+              <a:rPr lang="en-US" sz="1100" i="1" dirty="0">
+                <a:latin typeface="Source Sans Pro" panose="020B0503030403020204" pitchFamily="34" charset="0"/>
+                <a:ea typeface="Source Sans Pro" panose="020B0503030403020204" pitchFamily="34" charset="0"/>
+              </a:rPr>
+              <a:t>Northeastern University MOBS GLEAM COVID</a:t>
+            </a:r>
+            <a:r>
+              <a:rPr lang="en-US" sz="1100" dirty="0">
+                <a:latin typeface="Source Sans Pro" panose="020B0503030403020204" pitchFamily="34" charset="0"/>
+                <a:ea typeface="Source Sans Pro" panose="020B0503030403020204" pitchFamily="34" charset="0"/>
+              </a:rPr>
+              <a:t>: Matteo Chinazzi, Jessica T. Davis,  </a:t>
+            </a:r>
+            <a:r>
+              <a:rPr lang="en-US" sz="1100" dirty="0" err="1">
+                <a:latin typeface="Source Sans Pro" panose="020B0503030403020204" pitchFamily="34" charset="0"/>
+                <a:ea typeface="Source Sans Pro" panose="020B0503030403020204" pitchFamily="34" charset="0"/>
+              </a:rPr>
+              <a:t>Kunpeng</a:t>
+            </a:r>
+            <a:r>
+              <a:rPr lang="en-US" sz="1100" dirty="0">
+                <a:latin typeface="Source Sans Pro" panose="020B0503030403020204" pitchFamily="34" charset="0"/>
+                <a:ea typeface="Source Sans Pro" panose="020B0503030403020204" pitchFamily="34" charset="0"/>
+              </a:rPr>
+              <a:t> Mu, </a:t>
+            </a:r>
+            <a:r>
+              <a:rPr lang="en-US" sz="1100" dirty="0" err="1">
+                <a:latin typeface="Source Sans Pro" panose="020B0503030403020204" pitchFamily="34" charset="0"/>
+                <a:ea typeface="Source Sans Pro" panose="020B0503030403020204" pitchFamily="34" charset="0"/>
+              </a:rPr>
+              <a:t>Xinyue</a:t>
+            </a:r>
+            <a:r>
+              <a:rPr lang="en-US" sz="1100" dirty="0">
+                <a:latin typeface="Source Sans Pro" panose="020B0503030403020204" pitchFamily="34" charset="0"/>
+                <a:ea typeface="Source Sans Pro" panose="020B0503030403020204" pitchFamily="34" charset="0"/>
+              </a:rPr>
+              <a:t> </a:t>
+            </a:r>
+            <a:r>
+              <a:rPr lang="en-US" sz="1100" dirty="0" err="1">
+                <a:latin typeface="Source Sans Pro" panose="020B0503030403020204" pitchFamily="34" charset="0"/>
+                <a:ea typeface="Source Sans Pro" panose="020B0503030403020204" pitchFamily="34" charset="0"/>
+              </a:rPr>
+              <a:t>Xiong</a:t>
+            </a:r>
+            <a:r>
+              <a:rPr lang="en-US" sz="1100" dirty="0">
+                <a:latin typeface="Source Sans Pro" panose="020B0503030403020204" pitchFamily="34" charset="0"/>
+                <a:ea typeface="Source Sans Pro" panose="020B0503030403020204" pitchFamily="34" charset="0"/>
+              </a:rPr>
+              <a:t>, </a:t>
+            </a:r>
+            <a:br>
+              <a:rPr lang="en-US" sz="1100" dirty="0">
+                <a:latin typeface="Source Sans Pro" panose="020B0503030403020204" pitchFamily="34" charset="0"/>
+                <a:ea typeface="Source Sans Pro" panose="020B0503030403020204" pitchFamily="34" charset="0"/>
+              </a:rPr>
+            </a:br>
+            <a:r>
+              <a:rPr lang="en-US" sz="1100" dirty="0">
+                <a:latin typeface="Source Sans Pro" panose="020B0503030403020204" pitchFamily="34" charset="0"/>
+                <a:ea typeface="Source Sans Pro" panose="020B0503030403020204" pitchFamily="34" charset="0"/>
+              </a:rPr>
+              <a:t>Ana Pastore y Piontti, Alessandro Vespignani</a:t>
+            </a:r>
+          </a:p>
+          <a:p>
+            <a:r>
+              <a:rPr lang="en-US" sz="1100" i="1" dirty="0">
+                <a:latin typeface="Source Sans Pro" panose="020B0503030403020204" pitchFamily="34" charset="0"/>
+                <a:ea typeface="Source Sans Pro" panose="020B0503030403020204" pitchFamily="34" charset="0"/>
+              </a:rPr>
+              <a:t>University of Florida – ABM</a:t>
+            </a:r>
+            <a:r>
+              <a:rPr lang="en-US" sz="1100" dirty="0">
+                <a:latin typeface="Source Sans Pro" panose="020B0503030403020204" pitchFamily="34" charset="0"/>
+                <a:ea typeface="Source Sans Pro" panose="020B0503030403020204" pitchFamily="34" charset="0"/>
+              </a:rPr>
+              <a:t>: Thomas </a:t>
+            </a:r>
+            <a:r>
+              <a:rPr lang="en-US" sz="1100" dirty="0" err="1">
+                <a:latin typeface="Source Sans Pro" panose="020B0503030403020204" pitchFamily="34" charset="0"/>
+                <a:ea typeface="Source Sans Pro" panose="020B0503030403020204" pitchFamily="34" charset="0"/>
+              </a:rPr>
+              <a:t>Hladish</a:t>
+            </a:r>
+            <a:r>
+              <a:rPr lang="en-US" sz="1100" dirty="0">
+                <a:latin typeface="Source Sans Pro" panose="020B0503030403020204" pitchFamily="34" charset="0"/>
+                <a:ea typeface="Source Sans Pro" panose="020B0503030403020204" pitchFamily="34" charset="0"/>
+              </a:rPr>
+              <a:t>, </a:t>
+            </a:r>
+            <a:r>
+              <a:rPr lang="en-US" sz="1100" dirty="0" err="1">
+                <a:latin typeface="Source Sans Pro" panose="020B0503030403020204" pitchFamily="34" charset="0"/>
+                <a:ea typeface="Source Sans Pro" panose="020B0503030403020204" pitchFamily="34" charset="0"/>
+              </a:rPr>
+              <a:t>Alexandar</a:t>
+            </a:r>
+            <a:r>
+              <a:rPr lang="en-US" sz="1100" dirty="0">
+                <a:latin typeface="Source Sans Pro" panose="020B0503030403020204" pitchFamily="34" charset="0"/>
+                <a:ea typeface="Source Sans Pro" panose="020B0503030403020204" pitchFamily="34" charset="0"/>
+              </a:rPr>
+              <a:t> Pillai, </a:t>
+            </a:r>
+            <a:r>
+              <a:rPr lang="en-US" sz="1100" dirty="0" err="1">
+                <a:latin typeface="Source Sans Pro" panose="020B0503030403020204" pitchFamily="34" charset="0"/>
+                <a:ea typeface="Source Sans Pro" panose="020B0503030403020204" pitchFamily="34" charset="0"/>
+              </a:rPr>
+              <a:t>Kok</a:t>
+            </a:r>
+            <a:r>
+              <a:rPr lang="en-US" sz="1100" dirty="0">
+                <a:latin typeface="Source Sans Pro" panose="020B0503030403020204" pitchFamily="34" charset="0"/>
+                <a:ea typeface="Source Sans Pro" panose="020B0503030403020204" pitchFamily="34" charset="0"/>
+              </a:rPr>
+              <a:t> Ben </a:t>
+            </a:r>
+            <a:r>
+              <a:rPr lang="en-US" sz="1100" dirty="0" err="1">
+                <a:latin typeface="Source Sans Pro" panose="020B0503030403020204" pitchFamily="34" charset="0"/>
+                <a:ea typeface="Source Sans Pro" panose="020B0503030403020204" pitchFamily="34" charset="0"/>
+              </a:rPr>
+              <a:t>Toh</a:t>
+            </a:r>
+            <a:r>
+              <a:rPr lang="en-US" sz="1100" dirty="0">
+                <a:latin typeface="Source Sans Pro" panose="020B0503030403020204" pitchFamily="34" charset="0"/>
+                <a:ea typeface="Source Sans Pro" panose="020B0503030403020204" pitchFamily="34" charset="0"/>
+              </a:rPr>
+              <a:t>, Ira </a:t>
+            </a:r>
+            <a:r>
+              <a:rPr lang="en-US" sz="1100" dirty="0" err="1">
+                <a:latin typeface="Source Sans Pro" panose="020B0503030403020204" pitchFamily="34" charset="0"/>
+                <a:ea typeface="Source Sans Pro" panose="020B0503030403020204" pitchFamily="34" charset="0"/>
+              </a:rPr>
+              <a:t>Longini</a:t>
+            </a:r>
+            <a:r>
+              <a:rPr lang="en-US" sz="1100" dirty="0">
+                <a:latin typeface="Source Sans Pro" panose="020B0503030403020204" pitchFamily="34" charset="0"/>
+                <a:ea typeface="Source Sans Pro" panose="020B0503030403020204" pitchFamily="34" charset="0"/>
+              </a:rPr>
+              <a:t> Jr. </a:t>
+            </a:r>
+          </a:p>
+          <a:p>
+            <a:r>
+              <a:rPr lang="en-US" sz="1100" i="1" dirty="0">
+                <a:latin typeface="Source Sans Pro" panose="020B0503030403020204" pitchFamily="34" charset="0"/>
+                <a:ea typeface="Source Sans Pro" panose="020B0503030403020204" pitchFamily="34" charset="0"/>
+              </a:rPr>
+              <a:t>University of North Carolina at Charlotte – UNCC-</a:t>
+            </a:r>
+            <a:r>
+              <a:rPr lang="en-US" sz="1100" i="1" dirty="0" err="1">
+                <a:latin typeface="Source Sans Pro" panose="020B0503030403020204" pitchFamily="34" charset="0"/>
+                <a:ea typeface="Source Sans Pro" panose="020B0503030403020204" pitchFamily="34" charset="0"/>
+              </a:rPr>
+              <a:t>hierbin</a:t>
+            </a:r>
+            <a:r>
+              <a:rPr lang="en-US" sz="1100" dirty="0">
+                <a:latin typeface="Source Sans Pro" panose="020B0503030403020204" pitchFamily="34" charset="0"/>
+                <a:ea typeface="Source Sans Pro" panose="020B0503030403020204" pitchFamily="34" charset="0"/>
+              </a:rPr>
+              <a:t>: Shi Chen, </a:t>
+            </a:r>
+            <a:r>
+              <a:rPr lang="en-US" sz="1100" dirty="0" err="1">
+                <a:latin typeface="Source Sans Pro" panose="020B0503030403020204" pitchFamily="34" charset="0"/>
+                <a:ea typeface="Source Sans Pro" panose="020B0503030403020204" pitchFamily="34" charset="0"/>
+              </a:rPr>
+              <a:t>Rajib</a:t>
+            </a:r>
+            <a:r>
+              <a:rPr lang="en-US" sz="1100" dirty="0">
+                <a:latin typeface="Source Sans Pro" panose="020B0503030403020204" pitchFamily="34" charset="0"/>
+                <a:ea typeface="Source Sans Pro" panose="020B0503030403020204" pitchFamily="34" charset="0"/>
+              </a:rPr>
+              <a:t> Paul, Daniel </a:t>
+            </a:r>
+            <a:r>
+              <a:rPr lang="en-US" sz="1100" dirty="0" err="1">
+                <a:latin typeface="Source Sans Pro" panose="020B0503030403020204" pitchFamily="34" charset="0"/>
+                <a:ea typeface="Source Sans Pro" panose="020B0503030403020204" pitchFamily="34" charset="0"/>
+              </a:rPr>
+              <a:t>Janies</a:t>
+            </a:r>
+            <a:r>
+              <a:rPr lang="en-US" sz="1100" dirty="0">
+                <a:latin typeface="Source Sans Pro" panose="020B0503030403020204" pitchFamily="34" charset="0"/>
+                <a:ea typeface="Source Sans Pro" panose="020B0503030403020204" pitchFamily="34" charset="0"/>
+              </a:rPr>
+              <a:t>, Jen-Claude Thill</a:t>
+            </a:r>
+          </a:p>
+          <a:p>
+            <a:r>
+              <a:rPr lang="en-US" sz="1100" i="1" dirty="0">
+                <a:latin typeface="Source Sans Pro" panose="020B0503030403020204" pitchFamily="34" charset="0"/>
+                <a:ea typeface="Source Sans Pro" panose="020B0503030403020204" pitchFamily="34" charset="0"/>
+              </a:rPr>
+              <a:t>University of Notre Dame - FRED</a:t>
+            </a:r>
+            <a:r>
+              <a:rPr lang="en-US" sz="1100" dirty="0">
+                <a:latin typeface="Source Sans Pro" panose="020B0503030403020204" pitchFamily="34" charset="0"/>
+                <a:ea typeface="Source Sans Pro" panose="020B0503030403020204" pitchFamily="34" charset="0"/>
+              </a:rPr>
+              <a:t>: Guido </a:t>
+            </a:r>
+            <a:r>
+              <a:rPr lang="en-US" sz="1100" dirty="0" err="1">
+                <a:latin typeface="Source Sans Pro" panose="020B0503030403020204" pitchFamily="34" charset="0"/>
+                <a:ea typeface="Source Sans Pro" panose="020B0503030403020204" pitchFamily="34" charset="0"/>
+              </a:rPr>
+              <a:t>Espana</a:t>
+            </a:r>
+            <a:r>
+              <a:rPr lang="en-US" sz="1100" dirty="0">
+                <a:latin typeface="Source Sans Pro" panose="020B0503030403020204" pitchFamily="34" charset="0"/>
+                <a:ea typeface="Source Sans Pro" panose="020B0503030403020204" pitchFamily="34" charset="0"/>
+              </a:rPr>
+              <a:t>, Sean </a:t>
+            </a:r>
+            <a:r>
+              <a:rPr lang="en-US" sz="1100" dirty="0" err="1">
+                <a:latin typeface="Source Sans Pro" panose="020B0503030403020204" pitchFamily="34" charset="0"/>
+                <a:ea typeface="Source Sans Pro" panose="020B0503030403020204" pitchFamily="34" charset="0"/>
+              </a:rPr>
+              <a:t>Cavany</a:t>
+            </a:r>
+            <a:r>
+              <a:rPr lang="en-US" sz="1100" dirty="0">
+                <a:latin typeface="Source Sans Pro" panose="020B0503030403020204" pitchFamily="34" charset="0"/>
+                <a:ea typeface="Source Sans Pro" panose="020B0503030403020204" pitchFamily="34" charset="0"/>
+              </a:rPr>
+              <a:t>, Sean Moore, Alex Perkins</a:t>
+            </a:r>
+          </a:p>
+          <a:p>
+            <a:r>
+              <a:rPr lang="en-US" sz="1100" i="1" dirty="0">
+                <a:latin typeface="Source Sans Pro" panose="020B0503030403020204" pitchFamily="34" charset="0"/>
+                <a:ea typeface="Source Sans Pro" panose="020B0503030403020204" pitchFamily="34" charset="0"/>
+              </a:rPr>
+              <a:t>University Southern California </a:t>
+            </a:r>
+            <a:r>
+              <a:rPr lang="en-US" sz="1100" i="1" dirty="0" err="1">
+                <a:latin typeface="Source Sans Pro" panose="020B0503030403020204" pitchFamily="34" charset="0"/>
+                <a:ea typeface="Source Sans Pro" panose="020B0503030403020204" pitchFamily="34" charset="0"/>
+              </a:rPr>
+              <a:t>SlkJalpha</a:t>
+            </a:r>
+            <a:r>
+              <a:rPr lang="en-US" sz="1100" dirty="0">
+                <a:latin typeface="Source Sans Pro" panose="020B0503030403020204" pitchFamily="34" charset="0"/>
+                <a:ea typeface="Source Sans Pro" panose="020B0503030403020204" pitchFamily="34" charset="0"/>
+              </a:rPr>
+              <a:t>: </a:t>
+            </a:r>
+            <a:r>
+              <a:rPr lang="fi-FI" sz="1100" dirty="0" err="1">
+                <a:latin typeface="Source Sans Pro" panose="020B0503030403020204" pitchFamily="34" charset="0"/>
+                <a:ea typeface="Source Sans Pro" panose="020B0503030403020204" pitchFamily="34" charset="0"/>
+              </a:rPr>
+              <a:t>Ajitesh</a:t>
+            </a:r>
+            <a:r>
+              <a:rPr lang="fi-FI" sz="1100" dirty="0">
+                <a:latin typeface="Source Sans Pro" panose="020B0503030403020204" pitchFamily="34" charset="0"/>
+                <a:ea typeface="Source Sans Pro" panose="020B0503030403020204" pitchFamily="34" charset="0"/>
+              </a:rPr>
+              <a:t> </a:t>
+            </a:r>
+            <a:r>
+              <a:rPr lang="fi-FI" sz="1100" dirty="0" err="1">
+                <a:latin typeface="Source Sans Pro" panose="020B0503030403020204" pitchFamily="34" charset="0"/>
+                <a:ea typeface="Source Sans Pro" panose="020B0503030403020204" pitchFamily="34" charset="0"/>
+              </a:rPr>
+              <a:t>Srivastava</a:t>
+            </a:r>
+            <a:r>
+              <a:rPr lang="fi-FI" sz="1100" dirty="0">
+                <a:latin typeface="Source Sans Pro" panose="020B0503030403020204" pitchFamily="34" charset="0"/>
+                <a:ea typeface="Source Sans Pro" panose="020B0503030403020204" pitchFamily="34" charset="0"/>
+              </a:rPr>
+              <a:t>, </a:t>
+            </a:r>
+            <a:r>
+              <a:rPr lang="fi-FI" sz="1100" dirty="0" err="1">
+                <a:latin typeface="Source Sans Pro" panose="020B0503030403020204" pitchFamily="34" charset="0"/>
+                <a:ea typeface="Source Sans Pro" panose="020B0503030403020204" pitchFamily="34" charset="0"/>
+              </a:rPr>
+              <a:t>Majd</a:t>
+            </a:r>
+            <a:r>
+              <a:rPr lang="fi-FI" sz="1100" dirty="0">
+                <a:latin typeface="Source Sans Pro" panose="020B0503030403020204" pitchFamily="34" charset="0"/>
+                <a:ea typeface="Source Sans Pro" panose="020B0503030403020204" pitchFamily="34" charset="0"/>
+              </a:rPr>
+              <a:t> </a:t>
+            </a:r>
+            <a:r>
+              <a:rPr lang="fi-FI" sz="1100" dirty="0" err="1">
+                <a:latin typeface="Source Sans Pro" panose="020B0503030403020204" pitchFamily="34" charset="0"/>
+                <a:ea typeface="Source Sans Pro" panose="020B0503030403020204" pitchFamily="34" charset="0"/>
+              </a:rPr>
+              <a:t>Al</a:t>
+            </a:r>
+            <a:r>
+              <a:rPr lang="fi-FI" sz="1100" dirty="0">
+                <a:latin typeface="Source Sans Pro" panose="020B0503030403020204" pitchFamily="34" charset="0"/>
+                <a:ea typeface="Source Sans Pro" panose="020B0503030403020204" pitchFamily="34" charset="0"/>
+              </a:rPr>
+              <a:t> </a:t>
+            </a:r>
+            <a:r>
+              <a:rPr lang="fi-FI" sz="1100" dirty="0" err="1">
+                <a:latin typeface="Source Sans Pro" panose="020B0503030403020204" pitchFamily="34" charset="0"/>
+                <a:ea typeface="Source Sans Pro" panose="020B0503030403020204" pitchFamily="34" charset="0"/>
+              </a:rPr>
+              <a:t>Aawar</a:t>
+            </a:r>
+            <a:endParaRPr lang="fi-FI" sz="1100" dirty="0">
+              <a:latin typeface="Source Sans Pro" panose="020B0503030403020204" pitchFamily="34" charset="0"/>
+              <a:ea typeface="Source Sans Pro" panose="020B0503030403020204" pitchFamily="34" charset="0"/>
+            </a:endParaRPr>
+          </a:p>
+          <a:p>
+            <a:r>
+              <a:rPr lang="fi-FI" sz="1100" i="1" dirty="0" err="1">
+                <a:latin typeface="Source Sans Pro" panose="020B0503030403020204" pitchFamily="34" charset="0"/>
+                <a:ea typeface="Source Sans Pro" panose="020B0503030403020204" pitchFamily="34" charset="0"/>
+              </a:rPr>
+              <a:t>University</a:t>
+            </a:r>
+            <a:r>
+              <a:rPr lang="fi-FI" sz="1100" i="1" dirty="0">
+                <a:latin typeface="Source Sans Pro" panose="020B0503030403020204" pitchFamily="34" charset="0"/>
+                <a:ea typeface="Source Sans Pro" panose="020B0503030403020204" pitchFamily="34" charset="0"/>
+              </a:rPr>
+              <a:t> of Texas at Austin-</a:t>
+            </a:r>
+            <a:r>
+              <a:rPr lang="fi-FI" sz="1100" i="1" dirty="0" err="1">
+                <a:latin typeface="Source Sans Pro" panose="020B0503030403020204" pitchFamily="34" charset="0"/>
+                <a:ea typeface="Source Sans Pro" panose="020B0503030403020204" pitchFamily="34" charset="0"/>
+              </a:rPr>
+              <a:t>ImmunoSEIRS</a:t>
+            </a:r>
+            <a:r>
+              <a:rPr lang="fi-FI" sz="1100" dirty="0">
+                <a:latin typeface="Source Sans Pro" panose="020B0503030403020204" pitchFamily="34" charset="0"/>
+                <a:ea typeface="Source Sans Pro" panose="020B0503030403020204" pitchFamily="34" charset="0"/>
+              </a:rPr>
+              <a:t>: </a:t>
+            </a:r>
+            <a:r>
+              <a:rPr lang="fi-FI" sz="1100" dirty="0" err="1">
+                <a:latin typeface="Source Sans Pro" panose="020B0503030403020204" pitchFamily="34" charset="0"/>
+                <a:ea typeface="Source Sans Pro" panose="020B0503030403020204" pitchFamily="34" charset="0"/>
+              </a:rPr>
+              <a:t>Anass</a:t>
+            </a:r>
+            <a:r>
+              <a:rPr lang="fi-FI" sz="1100" dirty="0">
+                <a:latin typeface="Source Sans Pro" panose="020B0503030403020204" pitchFamily="34" charset="0"/>
+                <a:ea typeface="Source Sans Pro" panose="020B0503030403020204" pitchFamily="34" charset="0"/>
+              </a:rPr>
+              <a:t> </a:t>
+            </a:r>
+            <a:r>
+              <a:rPr lang="fi-FI" sz="1100" dirty="0" err="1">
+                <a:latin typeface="Source Sans Pro" panose="020B0503030403020204" pitchFamily="34" charset="0"/>
+                <a:ea typeface="Source Sans Pro" panose="020B0503030403020204" pitchFamily="34" charset="0"/>
+              </a:rPr>
+              <a:t>Bouchnita</a:t>
+            </a:r>
+            <a:r>
+              <a:rPr lang="fi-FI" sz="1100" dirty="0">
+                <a:latin typeface="Source Sans Pro" panose="020B0503030403020204" pitchFamily="34" charset="0"/>
+                <a:ea typeface="Source Sans Pro" panose="020B0503030403020204" pitchFamily="34" charset="0"/>
+              </a:rPr>
+              <a:t>, Spencer Fox, Michael </a:t>
+            </a:r>
+            <a:r>
+              <a:rPr lang="fi-FI" sz="1100" dirty="0" err="1">
+                <a:latin typeface="Source Sans Pro" panose="020B0503030403020204" pitchFamily="34" charset="0"/>
+                <a:ea typeface="Source Sans Pro" panose="020B0503030403020204" pitchFamily="34" charset="0"/>
+              </a:rPr>
+              <a:t>Lachmann</a:t>
+            </a:r>
+            <a:r>
+              <a:rPr lang="fi-FI" sz="1100" dirty="0">
+                <a:latin typeface="Source Sans Pro" panose="020B0503030403020204" pitchFamily="34" charset="0"/>
+                <a:ea typeface="Source Sans Pro" panose="020B0503030403020204" pitchFamily="34" charset="0"/>
+              </a:rPr>
+              <a:t>, Lauren </a:t>
+            </a:r>
+            <a:r>
+              <a:rPr lang="fi-FI" sz="1100" dirty="0" err="1">
+                <a:latin typeface="Source Sans Pro" panose="020B0503030403020204" pitchFamily="34" charset="0"/>
+                <a:ea typeface="Source Sans Pro" panose="020B0503030403020204" pitchFamily="34" charset="0"/>
+              </a:rPr>
+              <a:t>Ancel</a:t>
+            </a:r>
+            <a:r>
+              <a:rPr lang="fi-FI" sz="1100" dirty="0">
+                <a:latin typeface="Source Sans Pro" panose="020B0503030403020204" pitchFamily="34" charset="0"/>
+                <a:ea typeface="Source Sans Pro" panose="020B0503030403020204" pitchFamily="34" charset="0"/>
+              </a:rPr>
+              <a:t> </a:t>
+            </a:r>
+            <a:r>
+              <a:rPr lang="fi-FI" sz="1100" dirty="0" err="1">
+                <a:latin typeface="Source Sans Pro" panose="020B0503030403020204" pitchFamily="34" charset="0"/>
+                <a:ea typeface="Source Sans Pro" panose="020B0503030403020204" pitchFamily="34" charset="0"/>
+              </a:rPr>
+              <a:t>Meyers</a:t>
+            </a:r>
+            <a:r>
+              <a:rPr lang="fi-FI" sz="1100" dirty="0">
+                <a:latin typeface="Source Sans Pro" panose="020B0503030403020204" pitchFamily="34" charset="0"/>
+                <a:ea typeface="Source Sans Pro" panose="020B0503030403020204" pitchFamily="34" charset="0"/>
+              </a:rPr>
+              <a:t>, </a:t>
+            </a:r>
+            <a:br>
+              <a:rPr lang="fi-FI" sz="1100" dirty="0">
+                <a:latin typeface="Source Sans Pro" panose="020B0503030403020204" pitchFamily="34" charset="0"/>
+                <a:ea typeface="Source Sans Pro" panose="020B0503030403020204" pitchFamily="34" charset="0"/>
+              </a:rPr>
+            </a:br>
+            <a:r>
+              <a:rPr lang="fi-FI" sz="1100" dirty="0">
+                <a:latin typeface="Source Sans Pro" panose="020B0503030403020204" pitchFamily="34" charset="0"/>
+                <a:ea typeface="Source Sans Pro" panose="020B0503030403020204" pitchFamily="34" charset="0"/>
+              </a:rPr>
+              <a:t>UT COVID-19 </a:t>
+            </a:r>
+            <a:r>
+              <a:rPr lang="fi-FI" sz="1100" dirty="0" err="1">
+                <a:latin typeface="Source Sans Pro" panose="020B0503030403020204" pitchFamily="34" charset="0"/>
+                <a:ea typeface="Source Sans Pro" panose="020B0503030403020204" pitchFamily="34" charset="0"/>
+              </a:rPr>
+              <a:t>Modeling</a:t>
+            </a:r>
+            <a:r>
+              <a:rPr lang="fi-FI" sz="1100" dirty="0">
+                <a:latin typeface="Source Sans Pro" panose="020B0503030403020204" pitchFamily="34" charset="0"/>
+                <a:ea typeface="Source Sans Pro" panose="020B0503030403020204" pitchFamily="34" charset="0"/>
+              </a:rPr>
+              <a:t> </a:t>
+            </a:r>
+            <a:r>
+              <a:rPr lang="fi-FI" sz="1100" dirty="0" err="1">
+                <a:latin typeface="Source Sans Pro" panose="020B0503030403020204" pitchFamily="34" charset="0"/>
+                <a:ea typeface="Source Sans Pro" panose="020B0503030403020204" pitchFamily="34" charset="0"/>
+              </a:rPr>
+              <a:t>Consortium</a:t>
+            </a:r>
+            <a:endParaRPr lang="fi-FI" sz="1100" dirty="0">
+              <a:latin typeface="Source Sans Pro" panose="020B0503030403020204" pitchFamily="34" charset="0"/>
+              <a:ea typeface="Source Sans Pro" panose="020B0503030403020204" pitchFamily="34" charset="0"/>
+            </a:endParaRPr>
+          </a:p>
+          <a:p>
+            <a:r>
+              <a:rPr lang="en-US" sz="1100" i="1" dirty="0">
+                <a:latin typeface="Source Sans Pro" panose="020B0503030403020204" pitchFamily="34" charset="0"/>
+                <a:ea typeface="Source Sans Pro" panose="020B0503030403020204" pitchFamily="34" charset="0"/>
+              </a:rPr>
+              <a:t>University of Victoria</a:t>
+            </a:r>
+            <a:r>
+              <a:rPr lang="en-US" sz="1100" dirty="0">
+                <a:latin typeface="Source Sans Pro" panose="020B0503030403020204" pitchFamily="34" charset="0"/>
+                <a:ea typeface="Source Sans Pro" panose="020B0503030403020204" pitchFamily="34" charset="0"/>
+              </a:rPr>
+              <a:t>: </a:t>
+            </a:r>
+            <a:r>
+              <a:rPr lang="fi-FI" sz="1100" dirty="0">
+                <a:latin typeface="Source Sans Pro" panose="020B0503030403020204" pitchFamily="34" charset="0"/>
+                <a:ea typeface="Source Sans Pro" panose="020B0503030403020204" pitchFamily="34" charset="0"/>
+              </a:rPr>
+              <a:t>Dean </a:t>
+            </a:r>
+            <a:r>
+              <a:rPr lang="fi-FI" sz="1100" dirty="0" err="1">
+                <a:latin typeface="Source Sans Pro" panose="020B0503030403020204" pitchFamily="34" charset="0"/>
+                <a:ea typeface="Source Sans Pro" panose="020B0503030403020204" pitchFamily="34" charset="0"/>
+              </a:rPr>
+              <a:t>Karlen</a:t>
+            </a:r>
+            <a:endParaRPr lang="fi-FI" sz="1100" dirty="0">
+              <a:latin typeface="Source Sans Pro" panose="020B0503030403020204" pitchFamily="34" charset="0"/>
+              <a:ea typeface="Source Sans Pro" panose="020B0503030403020204" pitchFamily="34" charset="0"/>
+            </a:endParaRPr>
+          </a:p>
+          <a:p>
+            <a:r>
+              <a:rPr lang="en-US" sz="1100" i="1" dirty="0">
+                <a:latin typeface="Source Sans Pro" panose="020B0503030403020204" pitchFamily="34" charset="0"/>
+                <a:ea typeface="Source Sans Pro" panose="020B0503030403020204" pitchFamily="34" charset="0"/>
+              </a:rPr>
+              <a:t>University of Virginia-adaptive: </a:t>
+            </a:r>
+            <a:r>
+              <a:rPr lang="en-US" sz="1100" dirty="0" err="1">
+                <a:latin typeface="Source Sans Pro" panose="020B0503030403020204" pitchFamily="34" charset="0"/>
+                <a:ea typeface="Source Sans Pro" panose="020B0503030403020204" pitchFamily="34" charset="0"/>
+              </a:rPr>
+              <a:t>Przemyslaw</a:t>
+            </a:r>
+            <a:r>
+              <a:rPr lang="en-US" sz="1100" dirty="0">
+                <a:latin typeface="Source Sans Pro" panose="020B0503030403020204" pitchFamily="34" charset="0"/>
+                <a:ea typeface="Source Sans Pro" panose="020B0503030403020204" pitchFamily="34" charset="0"/>
+              </a:rPr>
+              <a:t> </a:t>
+            </a:r>
+            <a:r>
+              <a:rPr lang="en-US" sz="1100" dirty="0" err="1">
+                <a:latin typeface="Source Sans Pro" panose="020B0503030403020204" pitchFamily="34" charset="0"/>
+                <a:ea typeface="Source Sans Pro" panose="020B0503030403020204" pitchFamily="34" charset="0"/>
+              </a:rPr>
+              <a:t>Porebski</a:t>
+            </a:r>
+            <a:r>
+              <a:rPr lang="en-US" sz="1100" dirty="0">
+                <a:latin typeface="Source Sans Pro" panose="020B0503030403020204" pitchFamily="34" charset="0"/>
+                <a:ea typeface="Source Sans Pro" panose="020B0503030403020204" pitchFamily="34" charset="0"/>
+              </a:rPr>
+              <a:t>, Srini Venkatramanan, </a:t>
+            </a:r>
+            <a:r>
+              <a:rPr lang="en-US" sz="1100" dirty="0" err="1">
+                <a:latin typeface="Source Sans Pro" panose="020B0503030403020204" pitchFamily="34" charset="0"/>
+                <a:ea typeface="Source Sans Pro" panose="020B0503030403020204" pitchFamily="34" charset="0"/>
+              </a:rPr>
+              <a:t>Anniruddha</a:t>
+            </a:r>
+            <a:r>
+              <a:rPr lang="en-US" sz="1100" dirty="0">
+                <a:latin typeface="Source Sans Pro" panose="020B0503030403020204" pitchFamily="34" charset="0"/>
+                <a:ea typeface="Source Sans Pro" panose="020B0503030403020204" pitchFamily="34" charset="0"/>
+              </a:rPr>
+              <a:t> </a:t>
+            </a:r>
+            <a:r>
+              <a:rPr lang="en-US" sz="1100" dirty="0" err="1">
+                <a:latin typeface="Source Sans Pro" panose="020B0503030403020204" pitchFamily="34" charset="0"/>
+                <a:ea typeface="Source Sans Pro" panose="020B0503030403020204" pitchFamily="34" charset="0"/>
+              </a:rPr>
+              <a:t>Adiga</a:t>
+            </a:r>
+            <a:r>
+              <a:rPr lang="en-US" sz="1100" dirty="0">
+                <a:latin typeface="Source Sans Pro" panose="020B0503030403020204" pitchFamily="34" charset="0"/>
+                <a:ea typeface="Source Sans Pro" panose="020B0503030403020204" pitchFamily="34" charset="0"/>
+              </a:rPr>
+              <a:t>, Bryan Lewis, Brian </a:t>
+            </a:r>
+            <a:r>
+              <a:rPr lang="en-US" sz="1100" dirty="0" err="1">
+                <a:latin typeface="Source Sans Pro" panose="020B0503030403020204" pitchFamily="34" charset="0"/>
+                <a:ea typeface="Source Sans Pro" panose="020B0503030403020204" pitchFamily="34" charset="0"/>
+              </a:rPr>
+              <a:t>Klahn</a:t>
+            </a:r>
+            <a:r>
+              <a:rPr lang="en-US" sz="1100" dirty="0">
+                <a:latin typeface="Source Sans Pro" panose="020B0503030403020204" pitchFamily="34" charset="0"/>
+                <a:ea typeface="Source Sans Pro" panose="020B0503030403020204" pitchFamily="34" charset="0"/>
+              </a:rPr>
+              <a:t>, Joseph </a:t>
+            </a:r>
+            <a:r>
+              <a:rPr lang="en-US" sz="1100" dirty="0" err="1">
+                <a:latin typeface="Source Sans Pro" panose="020B0503030403020204" pitchFamily="34" charset="0"/>
+                <a:ea typeface="Source Sans Pro" panose="020B0503030403020204" pitchFamily="34" charset="0"/>
+              </a:rPr>
+              <a:t>Outten</a:t>
+            </a:r>
+            <a:r>
+              <a:rPr lang="en-US" sz="1100" dirty="0">
+                <a:latin typeface="Source Sans Pro" panose="020B0503030403020204" pitchFamily="34" charset="0"/>
+                <a:ea typeface="Source Sans Pro" panose="020B0503030403020204" pitchFamily="34" charset="0"/>
+              </a:rPr>
+              <a:t>, James </a:t>
+            </a:r>
+            <a:r>
+              <a:rPr lang="en-US" sz="1100" dirty="0" err="1">
+                <a:latin typeface="Source Sans Pro" panose="020B0503030403020204" pitchFamily="34" charset="0"/>
+                <a:ea typeface="Source Sans Pro" panose="020B0503030403020204" pitchFamily="34" charset="0"/>
+              </a:rPr>
+              <a:t>Schlitt</a:t>
+            </a:r>
+            <a:r>
+              <a:rPr lang="en-US" sz="1100" dirty="0">
+                <a:latin typeface="Source Sans Pro" panose="020B0503030403020204" pitchFamily="34" charset="0"/>
+                <a:ea typeface="Source Sans Pro" panose="020B0503030403020204" pitchFamily="34" charset="0"/>
+              </a:rPr>
+              <a:t>, </a:t>
+            </a:r>
+            <a:r>
+              <a:rPr lang="en-US" sz="1100" dirty="0" err="1">
+                <a:latin typeface="Source Sans Pro" panose="020B0503030403020204" pitchFamily="34" charset="0"/>
+                <a:ea typeface="Source Sans Pro" panose="020B0503030403020204" pitchFamily="34" charset="0"/>
+              </a:rPr>
+              <a:t>Patric</a:t>
+            </a:r>
+            <a:r>
+              <a:rPr lang="en-US" sz="1100" dirty="0">
+                <a:latin typeface="Source Sans Pro" panose="020B0503030403020204" pitchFamily="34" charset="0"/>
+                <a:ea typeface="Source Sans Pro" panose="020B0503030403020204" pitchFamily="34" charset="0"/>
+              </a:rPr>
+              <a:t> Corbett, </a:t>
+            </a:r>
+            <a:r>
+              <a:rPr lang="en-US" sz="1100" dirty="0" err="1">
+                <a:latin typeface="Source Sans Pro" panose="020B0503030403020204" pitchFamily="34" charset="0"/>
+                <a:ea typeface="Source Sans Pro" panose="020B0503030403020204" pitchFamily="34" charset="0"/>
+              </a:rPr>
+              <a:t>Pyrros</a:t>
+            </a:r>
+            <a:r>
+              <a:rPr lang="en-US" sz="1100" dirty="0">
+                <a:latin typeface="Source Sans Pro" panose="020B0503030403020204" pitchFamily="34" charset="0"/>
+                <a:ea typeface="Source Sans Pro" panose="020B0503030403020204" pitchFamily="34" charset="0"/>
+              </a:rPr>
+              <a:t> Alexander </a:t>
+            </a:r>
+            <a:r>
+              <a:rPr lang="en-US" sz="1100" dirty="0" err="1">
+                <a:latin typeface="Source Sans Pro" panose="020B0503030403020204" pitchFamily="34" charset="0"/>
+                <a:ea typeface="Source Sans Pro" panose="020B0503030403020204" pitchFamily="34" charset="0"/>
+              </a:rPr>
+              <a:t>Telionis</a:t>
+            </a:r>
+            <a:r>
+              <a:rPr lang="en-US" sz="1100" dirty="0">
+                <a:latin typeface="Source Sans Pro" panose="020B0503030403020204" pitchFamily="34" charset="0"/>
+                <a:ea typeface="Source Sans Pro" panose="020B0503030403020204" pitchFamily="34" charset="0"/>
+              </a:rPr>
+              <a:t>, </a:t>
+            </a:r>
+            <a:r>
+              <a:rPr lang="en-US" sz="1100" dirty="0" err="1">
+                <a:latin typeface="Source Sans Pro" panose="020B0503030403020204" pitchFamily="34" charset="0"/>
+                <a:ea typeface="Source Sans Pro" panose="020B0503030403020204" pitchFamily="34" charset="0"/>
+              </a:rPr>
+              <a:t>Lijing</a:t>
+            </a:r>
+            <a:r>
+              <a:rPr lang="en-US" sz="1100" dirty="0">
+                <a:latin typeface="Source Sans Pro" panose="020B0503030403020204" pitchFamily="34" charset="0"/>
+                <a:ea typeface="Source Sans Pro" panose="020B0503030403020204" pitchFamily="34" charset="0"/>
+              </a:rPr>
+              <a:t> Wang, Akhil Sai </a:t>
+            </a:r>
+            <a:r>
+              <a:rPr lang="en-US" sz="1100" dirty="0" err="1">
+                <a:latin typeface="Source Sans Pro" panose="020B0503030403020204" pitchFamily="34" charset="0"/>
+                <a:ea typeface="Source Sans Pro" panose="020B0503030403020204" pitchFamily="34" charset="0"/>
+              </a:rPr>
+              <a:t>Peddireddy</a:t>
+            </a:r>
+            <a:r>
+              <a:rPr lang="en-US" sz="1100" dirty="0">
+                <a:latin typeface="Source Sans Pro" panose="020B0503030403020204" pitchFamily="34" charset="0"/>
+                <a:ea typeface="Source Sans Pro" panose="020B0503030403020204" pitchFamily="34" charset="0"/>
+              </a:rPr>
+              <a:t>, Benjamin Hurt, </a:t>
+            </a:r>
+            <a:r>
+              <a:rPr lang="en-US" sz="1100" dirty="0" err="1">
+                <a:latin typeface="Source Sans Pro" panose="020B0503030403020204" pitchFamily="34" charset="0"/>
+                <a:ea typeface="Source Sans Pro" panose="020B0503030403020204" pitchFamily="34" charset="0"/>
+              </a:rPr>
+              <a:t>Jiangzhou</a:t>
+            </a:r>
+            <a:r>
+              <a:rPr lang="en-US" sz="1100" dirty="0">
+                <a:latin typeface="Source Sans Pro" panose="020B0503030403020204" pitchFamily="34" charset="0"/>
+                <a:ea typeface="Source Sans Pro" panose="020B0503030403020204" pitchFamily="34" charset="0"/>
+              </a:rPr>
+              <a:t> Chen, Anil </a:t>
+            </a:r>
+            <a:r>
+              <a:rPr lang="en-US" sz="1100" dirty="0" err="1">
+                <a:latin typeface="Source Sans Pro" panose="020B0503030403020204" pitchFamily="34" charset="0"/>
+                <a:ea typeface="Source Sans Pro" panose="020B0503030403020204" pitchFamily="34" charset="0"/>
+              </a:rPr>
+              <a:t>Vullikanti</a:t>
+            </a:r>
+            <a:r>
+              <a:rPr lang="en-US" sz="1100" dirty="0">
+                <a:latin typeface="Source Sans Pro" panose="020B0503030403020204" pitchFamily="34" charset="0"/>
+                <a:ea typeface="Source Sans Pro" panose="020B0503030403020204" pitchFamily="34" charset="0"/>
+              </a:rPr>
+              <a:t>, Madhav </a:t>
+            </a:r>
+            <a:r>
+              <a:rPr lang="en-US" sz="1100" dirty="0" err="1">
+                <a:latin typeface="Source Sans Pro" panose="020B0503030403020204" pitchFamily="34" charset="0"/>
+                <a:ea typeface="Source Sans Pro" panose="020B0503030403020204" pitchFamily="34" charset="0"/>
+              </a:rPr>
+              <a:t>Marathe</a:t>
+            </a:r>
+            <a:endParaRPr lang="en-US" sz="1100" dirty="0">
+              <a:latin typeface="Source Sans Pro" panose="020B0503030403020204" pitchFamily="34" charset="0"/>
+              <a:ea typeface="Source Sans Pro" panose="020B0503030403020204" pitchFamily="34" charset="0"/>
+            </a:endParaRPr>
+          </a:p>
+          <a:p>
+            <a:r>
+              <a:rPr lang="en-US" sz="1100" i="1" dirty="0">
+                <a:latin typeface="Source Sans Pro" panose="020B0503030403020204" pitchFamily="34" charset="0"/>
+                <a:ea typeface="Source Sans Pro" panose="020B0503030403020204" pitchFamily="34" charset="0"/>
+              </a:rPr>
+              <a:t>University of Virginia-</a:t>
+            </a:r>
+            <a:r>
+              <a:rPr lang="en-US" sz="1100" i="1" dirty="0" err="1">
+                <a:latin typeface="Source Sans Pro" panose="020B0503030403020204" pitchFamily="34" charset="0"/>
+                <a:ea typeface="Source Sans Pro" panose="020B0503030403020204" pitchFamily="34" charset="0"/>
+              </a:rPr>
+              <a:t>EpiHiper</a:t>
+            </a:r>
+            <a:r>
+              <a:rPr lang="en-US" sz="1100" dirty="0">
+                <a:latin typeface="Source Sans Pro" panose="020B0503030403020204" pitchFamily="34" charset="0"/>
+                <a:ea typeface="Source Sans Pro" panose="020B0503030403020204" pitchFamily="34" charset="0"/>
+              </a:rPr>
+              <a:t>: </a:t>
+            </a:r>
+            <a:r>
+              <a:rPr lang="en-US" sz="1100" dirty="0" err="1">
+                <a:latin typeface="Source Sans Pro" panose="020B0503030403020204" pitchFamily="34" charset="0"/>
+                <a:ea typeface="Source Sans Pro" panose="020B0503030403020204" pitchFamily="34" charset="0"/>
+              </a:rPr>
+              <a:t>Jiangzhuo</a:t>
+            </a:r>
+            <a:r>
+              <a:rPr lang="en-US" sz="1100" dirty="0">
+                <a:latin typeface="Source Sans Pro" panose="020B0503030403020204" pitchFamily="34" charset="0"/>
+                <a:ea typeface="Source Sans Pro" panose="020B0503030403020204" pitchFamily="34" charset="0"/>
+              </a:rPr>
+              <a:t> Chen, Stefan Hoops, </a:t>
+            </a:r>
+            <a:r>
+              <a:rPr lang="en-US" sz="1100" dirty="0" err="1">
+                <a:latin typeface="Source Sans Pro" panose="020B0503030403020204" pitchFamily="34" charset="0"/>
+                <a:ea typeface="Source Sans Pro" panose="020B0503030403020204" pitchFamily="34" charset="0"/>
+              </a:rPr>
+              <a:t>Parantapa</a:t>
+            </a:r>
+            <a:r>
+              <a:rPr lang="en-US" sz="1100" dirty="0">
+                <a:latin typeface="Source Sans Pro" panose="020B0503030403020204" pitchFamily="34" charset="0"/>
+                <a:ea typeface="Source Sans Pro" panose="020B0503030403020204" pitchFamily="34" charset="0"/>
+              </a:rPr>
+              <a:t> Bhattacharya, Dustin Machi, Bryan Lewis, </a:t>
+            </a:r>
+            <a:br>
+              <a:rPr lang="en-US" sz="1100" dirty="0">
+                <a:latin typeface="Source Sans Pro" panose="020B0503030403020204" pitchFamily="34" charset="0"/>
+                <a:ea typeface="Source Sans Pro" panose="020B0503030403020204" pitchFamily="34" charset="0"/>
+              </a:rPr>
+            </a:br>
+            <a:r>
+              <a:rPr lang="en-US" sz="1100" dirty="0">
+                <a:latin typeface="Source Sans Pro" panose="020B0503030403020204" pitchFamily="34" charset="0"/>
+                <a:ea typeface="Source Sans Pro" panose="020B0503030403020204" pitchFamily="34" charset="0"/>
+              </a:rPr>
+              <a:t>Madhav Marathe</a:t>
+            </a:r>
+          </a:p>
+          <a:p>
+            <a:endParaRPr lang="en-US" sz="1100" dirty="0">
+              <a:latin typeface="Source Sans Pro" panose="020B0503030403020204" pitchFamily="34" charset="0"/>
+              <a:ea typeface="Source Sans Pro" panose="020B0503030403020204" pitchFamily="34" charset="0"/>
+            </a:endParaRPr>
+          </a:p>
+          <a:p>
+            <a:r>
+              <a:rPr lang="en-US" sz="1400" b="1" dirty="0">
+                <a:solidFill>
+                  <a:srgbClr val="1FAEDB"/>
+                </a:solidFill>
+                <a:latin typeface="Source Sans Pro SemiBold" panose="020B0503030403020204" pitchFamily="34" charset="0"/>
+                <a:ea typeface="Source Sans Pro SemiBold" panose="020B0503030403020204" pitchFamily="34" charset="0"/>
+                <a:cs typeface="Arial Unicode MS" panose="020B0604020202020204" pitchFamily="34" charset="-128"/>
+              </a:rPr>
+              <a:t>Collaborators</a:t>
+            </a:r>
+            <a:br>
+              <a:rPr lang="en-US" sz="1400" b="1" dirty="0">
+                <a:solidFill>
+                  <a:srgbClr val="00B050"/>
+                </a:solidFill>
+                <a:latin typeface="Source Sans Pro SemiBold" panose="020B0503030403020204" pitchFamily="34" charset="0"/>
+                <a:ea typeface="Source Sans Pro SemiBold" panose="020B0503030403020204" pitchFamily="34" charset="0"/>
+                <a:cs typeface="Arial Unicode MS" panose="020B0604020202020204" pitchFamily="34" charset="-128"/>
+              </a:rPr>
+            </a:br>
+            <a:r>
+              <a:rPr lang="en-US" altLang="en-US" sz="1100" dirty="0">
+                <a:latin typeface="Source Sans Pro" panose="020B0503030403020204" pitchFamily="34" charset="0"/>
+                <a:ea typeface="Source Sans Pro" panose="020B0503030403020204" pitchFamily="34" charset="0"/>
+                <a:cs typeface="Times New Roman" panose="02020603050405020304" pitchFamily="18" charset="0"/>
+              </a:rPr>
+              <a:t>Matthew Biggerstaff, Michael Johansson, Rachel Slayton, Jessica Healey (CDC); </a:t>
+            </a:r>
+            <a:r>
+              <a:rPr lang="en-US" sz="1100" dirty="0">
+                <a:latin typeface="Source Sans Pro" panose="020B0503030403020204" pitchFamily="34" charset="0"/>
+                <a:ea typeface="Source Sans Pro" panose="020B0503030403020204" pitchFamily="34" charset="0"/>
+                <a:cs typeface="Times New Roman" panose="02020603050405020304" pitchFamily="18" charset="0"/>
+              </a:rPr>
+              <a:t>Nicole </a:t>
+            </a:r>
+            <a:r>
+              <a:rPr lang="en-US" sz="1100" dirty="0" err="1">
+                <a:latin typeface="Source Sans Pro" panose="020B0503030403020204" pitchFamily="34" charset="0"/>
+                <a:ea typeface="Source Sans Pro" panose="020B0503030403020204" pitchFamily="34" charset="0"/>
+                <a:cs typeface="Times New Roman" panose="02020603050405020304" pitchFamily="18" charset="0"/>
+              </a:rPr>
+              <a:t>Samay</a:t>
+            </a:r>
+            <a:r>
+              <a:rPr lang="en-US" sz="1100" dirty="0">
+                <a:latin typeface="Source Sans Pro" panose="020B0503030403020204" pitchFamily="34" charset="0"/>
+                <a:ea typeface="Source Sans Pro" panose="020B0503030403020204" pitchFamily="34" charset="0"/>
+                <a:cs typeface="Times New Roman" panose="02020603050405020304" pitchFamily="18" charset="0"/>
+              </a:rPr>
+              <a:t> (Northeastern University)</a:t>
+            </a:r>
+            <a:endParaRPr lang="en-US" sz="1100" dirty="0">
+              <a:latin typeface="Source Sans Pro" panose="020B0503030403020204" pitchFamily="34" charset="0"/>
+              <a:ea typeface="Source Sans Pro" panose="020B0503030403020204" pitchFamily="34" charset="0"/>
+            </a:endParaRPr>
+          </a:p>
+          <a:p>
+            <a:endParaRPr lang="en-US" sz="1100" dirty="0">
+              <a:latin typeface="Source Sans Pro" panose="020B0503030403020204" pitchFamily="34" charset="0"/>
+              <a:ea typeface="Source Sans Pro" panose="020B0503030403020204" pitchFamily="34" charset="0"/>
+            </a:endParaRPr>
+          </a:p>
+        </p:txBody>
+      </p:sp>
+      <p:grpSp>
+        <p:nvGrpSpPr>
+          <p:cNvPr id="38" name="Group 37">
+            <a:extLst>
+              <a:ext uri="{FF2B5EF4-FFF2-40B4-BE49-F238E27FC236}">
+                <a16:creationId xmlns:a16="http://schemas.microsoft.com/office/drawing/2014/main" id="{B2DDB30A-04EC-71CF-014A-0483893C789D}"/>
+              </a:ext>
+            </a:extLst>
+          </p:cNvPr>
+          <p:cNvGrpSpPr/>
+          <p:nvPr/>
+        </p:nvGrpSpPr>
+        <p:grpSpPr>
+          <a:xfrm>
+            <a:off x="807963" y="5713237"/>
+            <a:ext cx="3070729" cy="457200"/>
+            <a:chOff x="1074826" y="4366070"/>
+            <a:chExt cx="3070729" cy="457200"/>
+          </a:xfrm>
+        </p:grpSpPr>
+        <p:pic>
+          <p:nvPicPr>
+            <p:cNvPr id="14" name="Graphic 13" descr="Envelope with solid fill">
+              <a:extLst>
+                <a:ext uri="{FF2B5EF4-FFF2-40B4-BE49-F238E27FC236}">
+                  <a16:creationId xmlns:a16="http://schemas.microsoft.com/office/drawing/2014/main" id="{6C813C2C-5951-B2E7-85A4-D8E9BAA2125D}"/>
+                </a:ext>
+              </a:extLst>
+            </p:cNvPr>
+            <p:cNvPicPr>
+              <a:picLocks noChangeAspect="1"/>
+            </p:cNvPicPr>
+            <p:nvPr/>
+          </p:nvPicPr>
+          <p:blipFill>
+            <a:blip r:embed="rId4">
+              <a:extLst>
+                <a:ext uri="{28A0092B-C50C-407E-A947-70E740481C1C}">
+                  <a14:useLocalDpi xmlns:a14="http://schemas.microsoft.com/office/drawing/2010/main" val="0"/>
+                </a:ext>
+                <a:ext uri="{96DAC541-7B7A-43D3-8B79-37D633B846F1}">
+                  <asvg:svgBlip xmlns:asvg="http://schemas.microsoft.com/office/drawing/2016/SVG/main" r:embed="rId5"/>
+                </a:ext>
+              </a:extLst>
+            </a:blip>
+            <a:stretch>
+              <a:fillRect/>
+            </a:stretch>
+          </p:blipFill>
+          <p:spPr>
+            <a:xfrm>
+              <a:off x="1074826" y="4366070"/>
+              <a:ext cx="457200" cy="457200"/>
+            </a:xfrm>
+            <a:prstGeom prst="rect">
+              <a:avLst/>
+            </a:prstGeom>
+          </p:spPr>
+        </p:pic>
+        <p:sp>
+          <p:nvSpPr>
+            <p:cNvPr id="37" name="TextBox 36">
+              <a:extLst>
+                <a:ext uri="{FF2B5EF4-FFF2-40B4-BE49-F238E27FC236}">
+                  <a16:creationId xmlns:a16="http://schemas.microsoft.com/office/drawing/2014/main" id="{252CD946-866F-7EB7-C2A8-390D11F3D6D6}"/>
+                </a:ext>
+              </a:extLst>
+            </p:cNvPr>
+            <p:cNvSpPr txBox="1"/>
+            <p:nvPr/>
+          </p:nvSpPr>
+          <p:spPr>
+            <a:xfrm>
+              <a:off x="1556375" y="4383679"/>
+              <a:ext cx="2589180" cy="338554"/>
+            </a:xfrm>
+            <a:prstGeom prst="rect">
+              <a:avLst/>
+            </a:prstGeom>
+            <a:noFill/>
+          </p:spPr>
+          <p:txBody>
+            <a:bodyPr wrap="square">
+              <a:spAutoFit/>
+            </a:bodyPr>
+            <a:lstStyle/>
+            <a:p>
+              <a:r>
+                <a:rPr lang="en-US" sz="1600" dirty="0">
+                  <a:latin typeface="Source Sans Pro" panose="020B0503030403020204" pitchFamily="34" charset="0"/>
+                  <a:ea typeface="Source Sans Pro" panose="020B0503030403020204" pitchFamily="34" charset="0"/>
+                </a:rPr>
+                <a:t>jlessler@unc.edu</a:t>
+              </a:r>
+              <a:endParaRPr lang="en-US" sz="1600" dirty="0"/>
+            </a:p>
+          </p:txBody>
+        </p:sp>
+      </p:grpSp>
+      <p:pic>
+        <p:nvPicPr>
+          <p:cNvPr id="3" name="Picture 2" descr="SMH logo">
+            <a:extLst>
+              <a:ext uri="{FF2B5EF4-FFF2-40B4-BE49-F238E27FC236}">
+                <a16:creationId xmlns:a16="http://schemas.microsoft.com/office/drawing/2014/main" id="{A5569F7E-2273-370D-8EEF-F822AA3B1CF3}"/>
+              </a:ext>
+            </a:extLst>
+          </p:cNvPr>
+          <p:cNvPicPr>
+            <a:picLocks noChangeAspect="1" noChangeArrowheads="1"/>
+          </p:cNvPicPr>
+          <p:nvPr/>
+        </p:nvPicPr>
+        <p:blipFill>
+          <a:blip r:embed="rId6">
+            <a:extLst>
+              <a:ext uri="{28A0092B-C50C-407E-A947-70E740481C1C}">
+                <a14:useLocalDpi xmlns:a14="http://schemas.microsoft.com/office/drawing/2010/main" val="0"/>
+              </a:ext>
+            </a:extLst>
+          </a:blip>
+          <a:srcRect/>
+          <a:stretch>
+            <a:fillRect/>
+          </a:stretch>
+        </p:blipFill>
+        <p:spPr bwMode="auto">
+          <a:xfrm>
+            <a:off x="4680033" y="165549"/>
+            <a:ext cx="4470364" cy="799776"/>
+          </a:xfrm>
+          <a:prstGeom prst="rect">
+            <a:avLst/>
+          </a:prstGeom>
+          <a:noFill/>
+          <a:extLst>
+            <a:ext uri="{909E8E84-426E-40DD-AFC4-6F175D3DCCD1}">
+              <a14:hiddenFill xmlns:a14="http://schemas.microsoft.com/office/drawing/2010/main">
+                <a:solidFill>
+                  <a:srgbClr val="FFFFFF"/>
+                </a:solidFill>
+              </a14:hiddenFill>
+            </a:ext>
+          </a:extLst>
+        </p:spPr>
+      </p:pic>
+      <p:sp>
+        <p:nvSpPr>
+          <p:cNvPr id="43" name="TextBox 42">
+            <a:extLst>
+              <a:ext uri="{FF2B5EF4-FFF2-40B4-BE49-F238E27FC236}">
+                <a16:creationId xmlns:a16="http://schemas.microsoft.com/office/drawing/2014/main" id="{BF6A6401-3AC9-EAA9-5619-B56A0A2EFF95}"/>
+              </a:ext>
+            </a:extLst>
+          </p:cNvPr>
+          <p:cNvSpPr txBox="1"/>
+          <p:nvPr/>
+        </p:nvSpPr>
+        <p:spPr>
+          <a:xfrm>
+            <a:off x="552167" y="6211713"/>
+            <a:ext cx="3668682" cy="369332"/>
+          </a:xfrm>
+          <a:prstGeom prst="rect">
+            <a:avLst/>
+          </a:prstGeom>
+          <a:noFill/>
+        </p:spPr>
+        <p:txBody>
+          <a:bodyPr wrap="square">
+            <a:spAutoFit/>
+          </a:bodyPr>
+          <a:lstStyle/>
+          <a:p>
+            <a:r>
+              <a:rPr lang="en-US" dirty="0">
+                <a:solidFill>
+                  <a:srgbClr val="1EAEDB"/>
+                </a:solidFill>
+                <a:latin typeface="Helvetica Light" panose="020B0403020202020204" pitchFamily="34" charset="0"/>
+                <a:ea typeface="Source Sans Pro Light" panose="020B0403030403020204" pitchFamily="34" charset="0"/>
+                <a:hlinkClick r:id="rId7">
+                  <a:extLst>
+                    <a:ext uri="{A12FA001-AC4F-418D-AE19-62706E023703}">
+                      <ahyp:hlinkClr xmlns:ahyp="http://schemas.microsoft.com/office/drawing/2018/hyperlinkcolor" val="tx"/>
+                    </a:ext>
+                  </a:extLst>
+                </a:hlinkClick>
+              </a:rPr>
+              <a:t>https://scenariomodelinghub.org</a:t>
+            </a:r>
+            <a:r>
+              <a:rPr lang="en-US" dirty="0">
+                <a:solidFill>
+                  <a:srgbClr val="1EAEDB"/>
+                </a:solidFill>
+                <a:latin typeface="Helvetica Light" panose="020B0403020202020204" pitchFamily="34" charset="0"/>
+                <a:ea typeface="Source Sans Pro Light" panose="020B0403030403020204" pitchFamily="34" charset="0"/>
+              </a:rPr>
+              <a:t> </a:t>
+            </a:r>
+            <a:endParaRPr lang="en-US" dirty="0">
+              <a:solidFill>
+                <a:srgbClr val="1EAEDB"/>
+              </a:solidFill>
+            </a:endParaRPr>
+          </a:p>
+        </p:txBody>
+      </p:sp>
+      <p:pic>
+        <p:nvPicPr>
+          <p:cNvPr id="10" name="Picture 9">
+            <a:extLst>
+              <a:ext uri="{FF2B5EF4-FFF2-40B4-BE49-F238E27FC236}">
+                <a16:creationId xmlns:a16="http://schemas.microsoft.com/office/drawing/2014/main" id="{CA490C61-D2FC-73E4-C714-7B1C535B167E}"/>
+              </a:ext>
+            </a:extLst>
+          </p:cNvPr>
+          <p:cNvPicPr>
+            <a:picLocks noChangeAspect="1"/>
+          </p:cNvPicPr>
+          <p:nvPr/>
+        </p:nvPicPr>
+        <p:blipFill>
+          <a:blip r:embed="rId8"/>
+          <a:stretch>
+            <a:fillRect/>
+          </a:stretch>
+        </p:blipFill>
+        <p:spPr>
+          <a:xfrm>
+            <a:off x="709257" y="2503988"/>
+            <a:ext cx="2509910" cy="585747"/>
+          </a:xfrm>
+          <a:prstGeom prst="rect">
+            <a:avLst/>
+          </a:prstGeom>
+        </p:spPr>
+      </p:pic>
+      <p:pic>
+        <p:nvPicPr>
+          <p:cNvPr id="12" name="Picture 11">
+            <a:extLst>
+              <a:ext uri="{FF2B5EF4-FFF2-40B4-BE49-F238E27FC236}">
+                <a16:creationId xmlns:a16="http://schemas.microsoft.com/office/drawing/2014/main" id="{C4F1572B-924A-449A-5BC6-B29CCD9F6579}"/>
+              </a:ext>
+            </a:extLst>
+          </p:cNvPr>
+          <p:cNvPicPr>
+            <a:picLocks noChangeAspect="1"/>
+          </p:cNvPicPr>
+          <p:nvPr/>
+        </p:nvPicPr>
+        <p:blipFill>
+          <a:blip r:embed="rId9"/>
+          <a:stretch>
+            <a:fillRect/>
+          </a:stretch>
+        </p:blipFill>
+        <p:spPr>
+          <a:xfrm>
+            <a:off x="620182" y="3298502"/>
+            <a:ext cx="2653335" cy="773219"/>
+          </a:xfrm>
+          <a:prstGeom prst="rect">
+            <a:avLst/>
+          </a:prstGeom>
+        </p:spPr>
+      </p:pic>
+    </p:spTree>
+    <p:extLst>
+      <p:ext uri="{BB962C8B-B14F-4D97-AF65-F5344CB8AC3E}">
+        <p14:creationId xmlns:p14="http://schemas.microsoft.com/office/powerpoint/2010/main" val="3297556265"/>
+      </p:ext>
+    </p:extLst>
+  </p:cSld>
+  <p:clrMapOvr>
+    <a:masterClrMapping/>
+  </p:clrMapOvr>
+</p:sld>
+</file>
+
+<file path=ppt/slides/slide33.xml><?xml version="1.0" encoding="utf-8"?>
+<p:sld xmlns:a="http://schemas.openxmlformats.org/drawingml/2006/main" xmlns:r="http://schemas.openxmlformats.org/officeDocument/2006/relationships" xmlns:p="http://schemas.openxmlformats.org/presentationml/2006/main">
+  <p:cSld>
+    <p:spTree>
+      <p:nvGrpSpPr>
+        <p:cNvPr id="1" name=""/>
+        <p:cNvGrpSpPr/>
+        <p:nvPr/>
+      </p:nvGrpSpPr>
+      <p:grpSpPr>
+        <a:xfrm>
+          <a:off x="0" y="0"/>
+          <a:ext cx="0" cy="0"/>
+          <a:chOff x="0" y="0"/>
+          <a:chExt cx="0" cy="0"/>
+        </a:xfrm>
+      </p:grpSpPr>
       <p:sp>
         <p:nvSpPr>
           <p:cNvPr id="4" name="Title 3">
@@ -17513,7 +19293,7 @@
 </p:sld>
 </file>
 
-<file path=ppt/slides/slide33.xml><?xml version="1.0" encoding="utf-8"?>
+<file path=ppt/slides/slide34.xml><?xml version="1.0" encoding="utf-8"?>
 <p:sld xmlns:a="http://schemas.openxmlformats.org/drawingml/2006/main" xmlns:r="http://schemas.openxmlformats.org/officeDocument/2006/relationships" xmlns:p="http://schemas.openxmlformats.org/presentationml/2006/main">
   <p:cSld>
     <p:spTree>
@@ -18237,7 +20017,7 @@
 </p:sld>
 </file>
 
-<file path=ppt/slides/slide34.xml><?xml version="1.0" encoding="utf-8"?>
+<file path=ppt/slides/slide35.xml><?xml version="1.0" encoding="utf-8"?>
 <p:sld xmlns:a="http://schemas.openxmlformats.org/drawingml/2006/main" xmlns:r="http://schemas.openxmlformats.org/officeDocument/2006/relationships" xmlns:p="http://schemas.openxmlformats.org/presentationml/2006/main">
   <p:cSld>
     <p:spTree>
@@ -18748,7 +20528,7 @@
 </p:sld>
 </file>
 
-<file path=ppt/slides/slide35.xml><?xml version="1.0" encoding="utf-8"?>
+<file path=ppt/slides/slide36.xml><?xml version="1.0" encoding="utf-8"?>
 <p:sld xmlns:a="http://schemas.openxmlformats.org/drawingml/2006/main" xmlns:r="http://schemas.openxmlformats.org/officeDocument/2006/relationships" xmlns:p="http://schemas.openxmlformats.org/presentationml/2006/main">
   <p:cSld>
     <p:spTree>
@@ -19097,867 +20877,6 @@
       </p:transition>
     </mc:Fallback>
   </mc:AlternateContent>
-</p:sld>
-</file>
-
-<file path=ppt/slides/slide36.xml><?xml version="1.0" encoding="utf-8"?>
-<p:sld xmlns:a="http://schemas.openxmlformats.org/drawingml/2006/main" xmlns:r="http://schemas.openxmlformats.org/officeDocument/2006/relationships" xmlns:p="http://schemas.openxmlformats.org/presentationml/2006/main">
-  <p:cSld>
-    <p:spTree>
-      <p:nvGrpSpPr>
-        <p:cNvPr id="1" name=""/>
-        <p:cNvGrpSpPr/>
-        <p:nvPr/>
-      </p:nvGrpSpPr>
-      <p:grpSpPr>
-        <a:xfrm>
-          <a:off x="0" y="0"/>
-          <a:ext cx="0" cy="0"/>
-          <a:chOff x="0" y="0"/>
-          <a:chExt cx="0" cy="0"/>
-        </a:xfrm>
-      </p:grpSpPr>
-      <p:sp>
-        <p:nvSpPr>
-          <p:cNvPr id="2" name="Title 1">
-            <a:extLst>
-              <a:ext uri="{FF2B5EF4-FFF2-40B4-BE49-F238E27FC236}">
-                <a16:creationId xmlns:a16="http://schemas.microsoft.com/office/drawing/2014/main" id="{074F691B-EFA4-437F-B14F-D6015C14A46C}"/>
-              </a:ext>
-            </a:extLst>
-          </p:cNvPr>
-          <p:cNvSpPr>
-            <a:spLocks noGrp="1"/>
-          </p:cNvSpPr>
-          <p:nvPr>
-            <p:ph type="title"/>
-          </p:nvPr>
-        </p:nvSpPr>
-        <p:spPr>
-          <a:xfrm>
-            <a:off x="761999" y="2443565"/>
-            <a:ext cx="10811435" cy="1868486"/>
-          </a:xfrm>
-        </p:spPr>
-        <p:txBody>
-          <a:bodyPr>
-            <a:normAutofit fontScale="90000"/>
-          </a:bodyPr>
-          <a:lstStyle/>
-          <a:p>
-            <a:pPr algn="ctr"/>
-            <a:r>
-              <a:rPr lang="en-US" b="1" dirty="0">
-                <a:solidFill>
-                  <a:srgbClr val="8D372D"/>
-                </a:solidFill>
-                <a:latin typeface="+mn-lt"/>
-              </a:rPr>
-              <a:t>For Discussion: </a:t>
-            </a:r>
-            <a:r>
-              <a:rPr lang="en-US" b="1" dirty="0">
-                <a:solidFill>
-                  <a:srgbClr val="1B284F"/>
-                </a:solidFill>
-                <a:latin typeface="+mn-lt"/>
-              </a:rPr>
-              <a:t>Given that all scenarios are fundamentally counterfactual and should be evaluated in relation to how they inform action across multiple partners.</a:t>
-            </a:r>
-          </a:p>
-        </p:txBody>
-      </p:sp>
-    </p:spTree>
-    <p:extLst>
-      <p:ext uri="{BB962C8B-B14F-4D97-AF65-F5344CB8AC3E}">
-        <p14:creationId xmlns:p14="http://schemas.microsoft.com/office/powerpoint/2010/main" val="3164871708"/>
-      </p:ext>
-    </p:extLst>
-  </p:cSld>
-  <p:clrMapOvr>
-    <a:masterClrMapping/>
-  </p:clrMapOvr>
-  <mc:AlternateContent xmlns:mc="http://schemas.openxmlformats.org/markup-compatibility/2006" xmlns:p14="http://schemas.microsoft.com/office/powerpoint/2010/main">
-    <mc:Choice Requires="p14">
-      <p:transition spd="med" p14:dur="700">
-        <p:fade/>
-      </p:transition>
-    </mc:Choice>
-    <mc:Fallback xmlns="">
-      <p:transition spd="med">
-        <p:fade/>
-      </p:transition>
-    </mc:Fallback>
-  </mc:AlternateContent>
-</p:sld>
-</file>
-
-<file path=ppt/slides/slide37.xml><?xml version="1.0" encoding="utf-8"?>
-<p:sld xmlns:a="http://schemas.openxmlformats.org/drawingml/2006/main" xmlns:r="http://schemas.openxmlformats.org/officeDocument/2006/relationships" xmlns:p="http://schemas.openxmlformats.org/presentationml/2006/main">
-  <p:cSld>
-    <p:spTree>
-      <p:nvGrpSpPr>
-        <p:cNvPr id="1" name=""/>
-        <p:cNvGrpSpPr/>
-        <p:nvPr/>
-      </p:nvGrpSpPr>
-      <p:grpSpPr>
-        <a:xfrm>
-          <a:off x="0" y="0"/>
-          <a:ext cx="0" cy="0"/>
-          <a:chOff x="0" y="0"/>
-          <a:chExt cx="0" cy="0"/>
-        </a:xfrm>
-      </p:grpSpPr>
-      <mc:AlternateContent xmlns:mc="http://schemas.openxmlformats.org/markup-compatibility/2006">
-        <mc:Choice xmlns:a14="http://schemas.microsoft.com/office/drawing/2010/main" Requires="a14">
-          <p:sp>
-            <p:nvSpPr>
-              <p:cNvPr id="5" name="TextBox 4">
-                <a:extLst>
-                  <a:ext uri="{FF2B5EF4-FFF2-40B4-BE49-F238E27FC236}">
-                    <a16:creationId xmlns:a16="http://schemas.microsoft.com/office/drawing/2014/main" id="{04104A4E-AC5A-9FC0-8EE5-4B46D788C0FD}"/>
-                  </a:ext>
-                </a:extLst>
-              </p:cNvPr>
-              <p:cNvSpPr txBox="1"/>
-              <p:nvPr/>
-            </p:nvSpPr>
-            <p:spPr>
-              <a:xfrm>
-                <a:off x="5638107" y="2971800"/>
-                <a:ext cx="297902" cy="281937"/>
-              </a:xfrm>
-              <a:prstGeom prst="rect">
-                <a:avLst/>
-              </a:prstGeom>
-              <a:noFill/>
-            </p:spPr>
-            <p:txBody>
-              <a:bodyPr wrap="none" lIns="0" tIns="0" rIns="0" bIns="0" rtlCol="0">
-                <a:spAutoFit/>
-              </a:bodyPr>
-              <a:lstStyle/>
-              <a:p>
-                <a14:m>
-                  <m:oMathPara xmlns:m="http://schemas.openxmlformats.org/officeDocument/2006/math">
-                    <m:oMathParaPr>
-                      <m:jc m:val="centerGroup"/>
-                    </m:oMathParaPr>
-                    <m:oMath xmlns:m="http://schemas.openxmlformats.org/officeDocument/2006/math">
-                      <m:sSup>
-                        <m:sSupPr>
-                          <m:ctrlPr>
-                            <a:rPr lang="en-US" b="0" i="0" smtClean="0">
-                              <a:latin typeface="Cambria Math" panose="02040503050406030204" pitchFamily="18" charset="0"/>
-                            </a:rPr>
-                          </m:ctrlPr>
-                        </m:sSupPr>
-                        <m:e>
-                          <m:acc>
-                            <m:accPr>
-                              <m:chr m:val="̃"/>
-                              <m:ctrlPr>
-                                <a:rPr lang="en-US" b="0" i="1" smtClean="0">
-                                  <a:latin typeface="Cambria Math" panose="02040503050406030204" pitchFamily="18" charset="0"/>
-                                </a:rPr>
-                              </m:ctrlPr>
-                            </m:accPr>
-                            <m:e>
-                              <m:r>
-                                <a:rPr lang="en-US" b="0" i="1" smtClean="0">
-                                  <a:latin typeface="Cambria Math" panose="02040503050406030204" pitchFamily="18" charset="0"/>
-                                </a:rPr>
-                                <m:t>𝑋</m:t>
-                              </m:r>
-                            </m:e>
-                          </m:acc>
-                        </m:e>
-                        <m:sup>
-                          <m:r>
-                            <a:rPr lang="en-US" b="0" i="0" smtClean="0">
-                              <a:latin typeface="Cambria Math" panose="02040503050406030204" pitchFamily="18" charset="0"/>
-                            </a:rPr>
-                            <m:t>∗</m:t>
-                          </m:r>
-                        </m:sup>
-                      </m:sSup>
-                    </m:oMath>
-                  </m:oMathPara>
-                </a14:m>
-                <a:endParaRPr lang="en-US" b="0" dirty="0"/>
-              </a:p>
-            </p:txBody>
-          </p:sp>
-        </mc:Choice>
-        <mc:Fallback>
-          <p:sp>
-            <p:nvSpPr>
-              <p:cNvPr id="5" name="TextBox 4">
-                <a:extLst>
-                  <a:ext uri="{FF2B5EF4-FFF2-40B4-BE49-F238E27FC236}">
-                    <a16:creationId xmlns:a16="http://schemas.microsoft.com/office/drawing/2014/main" id="{04104A4E-AC5A-9FC0-8EE5-4B46D788C0FD}"/>
-                  </a:ext>
-                </a:extLst>
-              </p:cNvPr>
-              <p:cNvSpPr txBox="1">
-                <a:spLocks noRot="1" noChangeAspect="1" noMove="1" noResize="1" noEditPoints="1" noAdjustHandles="1" noChangeArrowheads="1" noChangeShapeType="1" noTextEdit="1"/>
-              </p:cNvSpPr>
-              <p:nvPr/>
-            </p:nvSpPr>
-            <p:spPr>
-              <a:xfrm>
-                <a:off x="5638107" y="2971800"/>
-                <a:ext cx="297902" cy="281937"/>
-              </a:xfrm>
-              <a:prstGeom prst="rect">
-                <a:avLst/>
-              </a:prstGeom>
-              <a:blipFill>
-                <a:blip r:embed="rId2"/>
-                <a:stretch>
-                  <a:fillRect l="-20408" t="-23913" r="-46939" b="-6522"/>
-                </a:stretch>
-              </a:blipFill>
-            </p:spPr>
-            <p:txBody>
-              <a:bodyPr/>
-              <a:lstStyle/>
-              <a:p>
-                <a:r>
-                  <a:rPr lang="en-US">
-                    <a:noFill/>
-                  </a:rPr>
-                  <a:t> </a:t>
-                </a:r>
-              </a:p>
-            </p:txBody>
-          </p:sp>
-        </mc:Fallback>
-      </mc:AlternateContent>
-      <mc:AlternateContent xmlns:mc="http://schemas.openxmlformats.org/markup-compatibility/2006">
-        <mc:Choice xmlns:a14="http://schemas.microsoft.com/office/drawing/2010/main" Requires="a14">
-          <p:sp>
-            <p:nvSpPr>
-              <p:cNvPr id="6" name="TextBox 5">
-                <a:extLst>
-                  <a:ext uri="{FF2B5EF4-FFF2-40B4-BE49-F238E27FC236}">
-                    <a16:creationId xmlns:a16="http://schemas.microsoft.com/office/drawing/2014/main" id="{FF945670-539F-C861-3476-93B65E49C862}"/>
-                  </a:ext>
-                </a:extLst>
-              </p:cNvPr>
-              <p:cNvSpPr txBox="1"/>
-              <p:nvPr/>
-            </p:nvSpPr>
-            <p:spPr>
-              <a:xfrm>
-                <a:off x="7702435" y="2542310"/>
-                <a:ext cx="297902" cy="276999"/>
-              </a:xfrm>
-              <a:prstGeom prst="rect">
-                <a:avLst/>
-              </a:prstGeom>
-              <a:noFill/>
-            </p:spPr>
-            <p:txBody>
-              <a:bodyPr wrap="square" lIns="0" tIns="0" rIns="0" bIns="0" rtlCol="0">
-                <a:spAutoFit/>
-              </a:bodyPr>
-              <a:lstStyle/>
-              <a:p>
-                <a14:m>
-                  <m:oMathPara xmlns:m="http://schemas.openxmlformats.org/officeDocument/2006/math">
-                    <m:oMathParaPr>
-                      <m:jc m:val="centerGroup"/>
-                    </m:oMathParaPr>
-                    <m:oMath xmlns:m="http://schemas.openxmlformats.org/officeDocument/2006/math">
-                      <m:sSup>
-                        <m:sSupPr>
-                          <m:ctrlPr>
-                            <a:rPr lang="en-US" b="0" i="1" smtClean="0">
-                              <a:latin typeface="Cambria Math" panose="02040503050406030204" pitchFamily="18" charset="0"/>
-                            </a:rPr>
-                          </m:ctrlPr>
-                        </m:sSupPr>
-                        <m:e>
-                          <m:r>
-                            <a:rPr lang="en-US" b="0" i="1" smtClean="0">
-                              <a:latin typeface="Cambria Math" panose="02040503050406030204" pitchFamily="18" charset="0"/>
-                            </a:rPr>
-                            <m:t>𝑦</m:t>
-                          </m:r>
-                        </m:e>
-                        <m:sup>
-                          <m:r>
-                            <a:rPr lang="en-US" b="0" i="1" smtClean="0">
-                              <a:latin typeface="Cambria Math" panose="02040503050406030204" pitchFamily="18" charset="0"/>
-                            </a:rPr>
-                            <m:t>∗</m:t>
-                          </m:r>
-                        </m:sup>
-                      </m:sSup>
-                    </m:oMath>
-                  </m:oMathPara>
-                </a14:m>
-                <a:endParaRPr lang="en-US" b="0" dirty="0"/>
-              </a:p>
-            </p:txBody>
-          </p:sp>
-        </mc:Choice>
-        <mc:Fallback>
-          <p:sp>
-            <p:nvSpPr>
-              <p:cNvPr id="6" name="TextBox 5">
-                <a:extLst>
-                  <a:ext uri="{FF2B5EF4-FFF2-40B4-BE49-F238E27FC236}">
-                    <a16:creationId xmlns:a16="http://schemas.microsoft.com/office/drawing/2014/main" id="{FF945670-539F-C861-3476-93B65E49C862}"/>
-                  </a:ext>
-                </a:extLst>
-              </p:cNvPr>
-              <p:cNvSpPr txBox="1">
-                <a:spLocks noRot="1" noChangeAspect="1" noMove="1" noResize="1" noEditPoints="1" noAdjustHandles="1" noChangeArrowheads="1" noChangeShapeType="1" noTextEdit="1"/>
-              </p:cNvSpPr>
-              <p:nvPr/>
-            </p:nvSpPr>
-            <p:spPr>
-              <a:xfrm>
-                <a:off x="7702435" y="2542310"/>
-                <a:ext cx="297902" cy="276999"/>
-              </a:xfrm>
-              <a:prstGeom prst="rect">
-                <a:avLst/>
-              </a:prstGeom>
-              <a:blipFill>
-                <a:blip r:embed="rId3"/>
-                <a:stretch>
-                  <a:fillRect l="-18750" r="-2083" b="-26667"/>
-                </a:stretch>
-              </a:blipFill>
-            </p:spPr>
-            <p:txBody>
-              <a:bodyPr/>
-              <a:lstStyle/>
-              <a:p>
-                <a:r>
-                  <a:rPr lang="en-US">
-                    <a:noFill/>
-                  </a:rPr>
-                  <a:t> </a:t>
-                </a:r>
-              </a:p>
-            </p:txBody>
-          </p:sp>
-        </mc:Fallback>
-      </mc:AlternateContent>
-      <mc:AlternateContent xmlns:mc="http://schemas.openxmlformats.org/markup-compatibility/2006">
-        <mc:Choice xmlns:a14="http://schemas.microsoft.com/office/drawing/2010/main" Requires="a14">
-          <p:sp>
-            <p:nvSpPr>
-              <p:cNvPr id="7" name="TextBox 6">
-                <a:extLst>
-                  <a:ext uri="{FF2B5EF4-FFF2-40B4-BE49-F238E27FC236}">
-                    <a16:creationId xmlns:a16="http://schemas.microsoft.com/office/drawing/2014/main" id="{45DD6DCB-FB76-9451-61A1-007C4F7BF312}"/>
-                  </a:ext>
-                </a:extLst>
-              </p:cNvPr>
-              <p:cNvSpPr txBox="1"/>
-              <p:nvPr/>
-            </p:nvSpPr>
-            <p:spPr>
-              <a:xfrm>
-                <a:off x="5434445" y="4335087"/>
-                <a:ext cx="779764" cy="281937"/>
-              </a:xfrm>
-              <a:prstGeom prst="rect">
-                <a:avLst/>
-              </a:prstGeom>
-              <a:noFill/>
-            </p:spPr>
-            <p:txBody>
-              <a:bodyPr wrap="none" lIns="0" tIns="0" rIns="0" bIns="0" rtlCol="0">
-                <a:spAutoFit/>
-              </a:bodyPr>
-              <a:lstStyle/>
-              <a:p>
-                <a14:m>
-                  <m:oMathPara xmlns:m="http://schemas.openxmlformats.org/officeDocument/2006/math">
-                    <m:oMathParaPr>
-                      <m:jc m:val="centerGroup"/>
-                    </m:oMathParaPr>
-                    <m:oMath xmlns:m="http://schemas.openxmlformats.org/officeDocument/2006/math">
-                      <m:sSub>
-                        <m:sSubPr>
-                          <m:ctrlPr>
-                            <a:rPr lang="en-US" b="0" i="1" smtClean="0">
-                              <a:latin typeface="Cambria Math" panose="02040503050406030204" pitchFamily="18" charset="0"/>
-                            </a:rPr>
-                          </m:ctrlPr>
-                        </m:sSubPr>
-                        <m:e>
-                          <m:acc>
-                            <m:accPr>
-                              <m:chr m:val="̃"/>
-                              <m:ctrlPr>
-                                <a:rPr lang="en-US" b="0" i="1" smtClean="0">
-                                  <a:latin typeface="Cambria Math" panose="02040503050406030204" pitchFamily="18" charset="0"/>
-                                </a:rPr>
-                              </m:ctrlPr>
-                            </m:accPr>
-                            <m:e>
-                              <m:r>
-                                <a:rPr lang="en-US" b="0" i="1" smtClean="0">
-                                  <a:latin typeface="Cambria Math" panose="02040503050406030204" pitchFamily="18" charset="0"/>
-                                </a:rPr>
-                                <m:t>𝑋</m:t>
-                              </m:r>
-                            </m:e>
-                          </m:acc>
-                        </m:e>
-                        <m:sub>
-                          <m:r>
-                            <a:rPr lang="en-US" b="0" i="1" smtClean="0">
-                              <a:latin typeface="Cambria Math" panose="02040503050406030204" pitchFamily="18" charset="0"/>
-                            </a:rPr>
-                            <m:t>𝑖</m:t>
-                          </m:r>
-                        </m:sub>
-                      </m:sSub>
-                      <m:r>
-                        <a:rPr lang="en-US" b="0" i="1" smtClean="0">
-                          <a:latin typeface="Cambria Math" panose="02040503050406030204" pitchFamily="18" charset="0"/>
-                        </a:rPr>
-                        <m:t>→</m:t>
-                      </m:r>
-                      <m:sSub>
-                        <m:sSubPr>
-                          <m:ctrlPr>
-                            <a:rPr lang="en-US" b="0" i="1" smtClean="0">
-                              <a:latin typeface="Cambria Math" panose="02040503050406030204" pitchFamily="18" charset="0"/>
-                            </a:rPr>
-                          </m:ctrlPr>
-                        </m:sSubPr>
-                        <m:e>
-                          <m:r>
-                            <a:rPr lang="en-US" b="0" i="1" smtClean="0">
-                              <a:latin typeface="Cambria Math" panose="02040503050406030204" pitchFamily="18" charset="0"/>
-                            </a:rPr>
-                            <m:t>𝑦</m:t>
-                          </m:r>
-                        </m:e>
-                        <m:sub>
-                          <m:r>
-                            <a:rPr lang="en-US" b="0" i="1" smtClean="0">
-                              <a:latin typeface="Cambria Math" panose="02040503050406030204" pitchFamily="18" charset="0"/>
-                            </a:rPr>
-                            <m:t>𝑖</m:t>
-                          </m:r>
-                        </m:sub>
-                      </m:sSub>
-                    </m:oMath>
-                  </m:oMathPara>
-                </a14:m>
-                <a:endParaRPr lang="en-US" dirty="0"/>
-              </a:p>
-            </p:txBody>
-          </p:sp>
-        </mc:Choice>
-        <mc:Fallback>
-          <p:sp>
-            <p:nvSpPr>
-              <p:cNvPr id="7" name="TextBox 6">
-                <a:extLst>
-                  <a:ext uri="{FF2B5EF4-FFF2-40B4-BE49-F238E27FC236}">
-                    <a16:creationId xmlns:a16="http://schemas.microsoft.com/office/drawing/2014/main" id="{45DD6DCB-FB76-9451-61A1-007C4F7BF312}"/>
-                  </a:ext>
-                </a:extLst>
-              </p:cNvPr>
-              <p:cNvSpPr txBox="1">
-                <a:spLocks noRot="1" noChangeAspect="1" noMove="1" noResize="1" noEditPoints="1" noAdjustHandles="1" noChangeArrowheads="1" noChangeShapeType="1" noTextEdit="1"/>
-              </p:cNvSpPr>
-              <p:nvPr/>
-            </p:nvSpPr>
-            <p:spPr>
-              <a:xfrm>
-                <a:off x="5434445" y="4335087"/>
-                <a:ext cx="779764" cy="281937"/>
-              </a:xfrm>
-              <a:prstGeom prst="rect">
-                <a:avLst/>
-              </a:prstGeom>
-              <a:blipFill>
-                <a:blip r:embed="rId4"/>
-                <a:stretch>
-                  <a:fillRect l="-7031" t="-21739" r="-3125" b="-26087"/>
-                </a:stretch>
-              </a:blipFill>
-            </p:spPr>
-            <p:txBody>
-              <a:bodyPr/>
-              <a:lstStyle/>
-              <a:p>
-                <a:r>
-                  <a:rPr lang="en-US">
-                    <a:noFill/>
-                  </a:rPr>
-                  <a:t> </a:t>
-                </a:r>
-              </a:p>
-            </p:txBody>
-          </p:sp>
-        </mc:Fallback>
-      </mc:AlternateContent>
-      <mc:AlternateContent xmlns:mc="http://schemas.openxmlformats.org/markup-compatibility/2006">
-        <mc:Choice xmlns:a14="http://schemas.microsoft.com/office/drawing/2010/main" Requires="a14">
-          <p:sp>
-            <p:nvSpPr>
-              <p:cNvPr id="8" name="TextBox 7">
-                <a:extLst>
-                  <a:ext uri="{FF2B5EF4-FFF2-40B4-BE49-F238E27FC236}">
-                    <a16:creationId xmlns:a16="http://schemas.microsoft.com/office/drawing/2014/main" id="{5B4B891F-C513-A733-1E12-D9B043505158}"/>
-                  </a:ext>
-                </a:extLst>
-              </p:cNvPr>
-              <p:cNvSpPr txBox="1"/>
-              <p:nvPr/>
-            </p:nvSpPr>
-            <p:spPr>
-              <a:xfrm>
-                <a:off x="3497580" y="2788920"/>
-                <a:ext cx="292772" cy="276999"/>
-              </a:xfrm>
-              <a:prstGeom prst="rect">
-                <a:avLst/>
-              </a:prstGeom>
-              <a:noFill/>
-            </p:spPr>
-            <p:txBody>
-              <a:bodyPr wrap="none" lIns="0" tIns="0" rIns="0" bIns="0" rtlCol="0">
-                <a:spAutoFit/>
-              </a:bodyPr>
-              <a:lstStyle/>
-              <a:p>
-                <a14:m>
-                  <m:oMathPara xmlns:m="http://schemas.openxmlformats.org/officeDocument/2006/math">
-                    <m:oMathParaPr>
-                      <m:jc m:val="centerGroup"/>
-                    </m:oMathParaPr>
-                    <m:oMath xmlns:m="http://schemas.openxmlformats.org/officeDocument/2006/math">
-                      <m:sSub>
-                        <m:sSubPr>
-                          <m:ctrlPr>
-                            <a:rPr lang="en-US" b="0" i="1" smtClean="0">
-                              <a:latin typeface="Cambria Math" panose="02040503050406030204" pitchFamily="18" charset="0"/>
-                            </a:rPr>
-                          </m:ctrlPr>
-                        </m:sSubPr>
-                        <m:e>
-                          <m:r>
-                            <a:rPr lang="en-US" b="0" i="1" smtClean="0">
-                              <a:latin typeface="Cambria Math" panose="02040503050406030204" pitchFamily="18" charset="0"/>
-                            </a:rPr>
-                            <m:t>𝑋</m:t>
-                          </m:r>
-                        </m:e>
-                        <m:sub>
-                          <m:r>
-                            <a:rPr lang="en-US" b="0" i="1" smtClean="0">
-                              <a:latin typeface="Cambria Math" panose="02040503050406030204" pitchFamily="18" charset="0"/>
-                            </a:rPr>
-                            <m:t>2</m:t>
-                          </m:r>
-                        </m:sub>
-                      </m:sSub>
-                    </m:oMath>
-                  </m:oMathPara>
-                </a14:m>
-                <a:endParaRPr lang="en-US" dirty="0"/>
-              </a:p>
-            </p:txBody>
-          </p:sp>
-        </mc:Choice>
-        <mc:Fallback>
-          <p:sp>
-            <p:nvSpPr>
-              <p:cNvPr id="8" name="TextBox 7">
-                <a:extLst>
-                  <a:ext uri="{FF2B5EF4-FFF2-40B4-BE49-F238E27FC236}">
-                    <a16:creationId xmlns:a16="http://schemas.microsoft.com/office/drawing/2014/main" id="{5B4B891F-C513-A733-1E12-D9B043505158}"/>
-                  </a:ext>
-                </a:extLst>
-              </p:cNvPr>
-              <p:cNvSpPr txBox="1">
-                <a:spLocks noRot="1" noChangeAspect="1" noMove="1" noResize="1" noEditPoints="1" noAdjustHandles="1" noChangeArrowheads="1" noChangeShapeType="1" noTextEdit="1"/>
-              </p:cNvSpPr>
-              <p:nvPr/>
-            </p:nvSpPr>
-            <p:spPr>
-              <a:xfrm>
-                <a:off x="3497580" y="2788920"/>
-                <a:ext cx="292772" cy="276999"/>
-              </a:xfrm>
-              <a:prstGeom prst="rect">
-                <a:avLst/>
-              </a:prstGeom>
-              <a:blipFill>
-                <a:blip r:embed="rId5"/>
-                <a:stretch>
-                  <a:fillRect l="-20833" r="-8333" b="-15556"/>
-                </a:stretch>
-              </a:blipFill>
-            </p:spPr>
-            <p:txBody>
-              <a:bodyPr/>
-              <a:lstStyle/>
-              <a:p>
-                <a:r>
-                  <a:rPr lang="en-US">
-                    <a:noFill/>
-                  </a:rPr>
-                  <a:t> </a:t>
-                </a:r>
-              </a:p>
-            </p:txBody>
-          </p:sp>
-        </mc:Fallback>
-      </mc:AlternateContent>
-      <mc:AlternateContent xmlns:mc="http://schemas.openxmlformats.org/markup-compatibility/2006">
-        <mc:Choice xmlns:a14="http://schemas.microsoft.com/office/drawing/2010/main" Requires="a14">
-          <p:sp>
-            <p:nvSpPr>
-              <p:cNvPr id="9" name="TextBox 8">
-                <a:extLst>
-                  <a:ext uri="{FF2B5EF4-FFF2-40B4-BE49-F238E27FC236}">
-                    <a16:creationId xmlns:a16="http://schemas.microsoft.com/office/drawing/2014/main" id="{65D8183B-F7EA-F9F8-89C1-7C4924D2B8DD}"/>
-                  </a:ext>
-                </a:extLst>
-              </p:cNvPr>
-              <p:cNvSpPr txBox="1"/>
-              <p:nvPr/>
-            </p:nvSpPr>
-            <p:spPr>
-              <a:xfrm>
-                <a:off x="2677391" y="2583873"/>
-                <a:ext cx="287451" cy="276999"/>
-              </a:xfrm>
-              <a:prstGeom prst="rect">
-                <a:avLst/>
-              </a:prstGeom>
-              <a:noFill/>
-            </p:spPr>
-            <p:txBody>
-              <a:bodyPr wrap="none" lIns="0" tIns="0" rIns="0" bIns="0" rtlCol="0">
-                <a:spAutoFit/>
-              </a:bodyPr>
-              <a:lstStyle/>
-              <a:p>
-                <a14:m>
-                  <m:oMathPara xmlns:m="http://schemas.openxmlformats.org/officeDocument/2006/math">
-                    <m:oMathParaPr>
-                      <m:jc m:val="centerGroup"/>
-                    </m:oMathParaPr>
-                    <m:oMath xmlns:m="http://schemas.openxmlformats.org/officeDocument/2006/math">
-                      <m:sSub>
-                        <m:sSubPr>
-                          <m:ctrlPr>
-                            <a:rPr lang="en-US" b="0" i="1" smtClean="0">
-                              <a:latin typeface="Cambria Math" panose="02040503050406030204" pitchFamily="18" charset="0"/>
-                            </a:rPr>
-                          </m:ctrlPr>
-                        </m:sSubPr>
-                        <m:e>
-                          <m:r>
-                            <a:rPr lang="en-US" b="0" i="1" smtClean="0">
-                              <a:latin typeface="Cambria Math" panose="02040503050406030204" pitchFamily="18" charset="0"/>
-                            </a:rPr>
-                            <m:t>𝑋</m:t>
-                          </m:r>
-                        </m:e>
-                        <m:sub>
-                          <m:r>
-                            <a:rPr lang="en-US" b="0" i="1" smtClean="0">
-                              <a:latin typeface="Cambria Math" panose="02040503050406030204" pitchFamily="18" charset="0"/>
-                            </a:rPr>
-                            <m:t>1</m:t>
-                          </m:r>
-                        </m:sub>
-                      </m:sSub>
-                    </m:oMath>
-                  </m:oMathPara>
-                </a14:m>
-                <a:endParaRPr lang="en-US" dirty="0"/>
-              </a:p>
-            </p:txBody>
-          </p:sp>
-        </mc:Choice>
-        <mc:Fallback>
-          <p:sp>
-            <p:nvSpPr>
-              <p:cNvPr id="9" name="TextBox 8">
-                <a:extLst>
-                  <a:ext uri="{FF2B5EF4-FFF2-40B4-BE49-F238E27FC236}">
-                    <a16:creationId xmlns:a16="http://schemas.microsoft.com/office/drawing/2014/main" id="{65D8183B-F7EA-F9F8-89C1-7C4924D2B8DD}"/>
-                  </a:ext>
-                </a:extLst>
-              </p:cNvPr>
-              <p:cNvSpPr txBox="1">
-                <a:spLocks noRot="1" noChangeAspect="1" noMove="1" noResize="1" noEditPoints="1" noAdjustHandles="1" noChangeArrowheads="1" noChangeShapeType="1" noTextEdit="1"/>
-              </p:cNvSpPr>
-              <p:nvPr/>
-            </p:nvSpPr>
-            <p:spPr>
-              <a:xfrm>
-                <a:off x="2677391" y="2583873"/>
-                <a:ext cx="287451" cy="276999"/>
-              </a:xfrm>
-              <a:prstGeom prst="rect">
-                <a:avLst/>
-              </a:prstGeom>
-              <a:blipFill>
-                <a:blip r:embed="rId6"/>
-                <a:stretch>
-                  <a:fillRect l="-19149" r="-10638" b="-15556"/>
-                </a:stretch>
-              </a:blipFill>
-            </p:spPr>
-            <p:txBody>
-              <a:bodyPr/>
-              <a:lstStyle/>
-              <a:p>
-                <a:r>
-                  <a:rPr lang="en-US">
-                    <a:noFill/>
-                  </a:rPr>
-                  <a:t> </a:t>
-                </a:r>
-              </a:p>
-            </p:txBody>
-          </p:sp>
-        </mc:Fallback>
-      </mc:AlternateContent>
-      <mc:AlternateContent xmlns:mc="http://schemas.openxmlformats.org/markup-compatibility/2006">
-        <mc:Choice xmlns:a14="http://schemas.microsoft.com/office/drawing/2010/main" Requires="a14">
-          <p:sp>
-            <p:nvSpPr>
-              <p:cNvPr id="10" name="TextBox 9">
-                <a:extLst>
-                  <a:ext uri="{FF2B5EF4-FFF2-40B4-BE49-F238E27FC236}">
-                    <a16:creationId xmlns:a16="http://schemas.microsoft.com/office/drawing/2014/main" id="{451AD6D5-55FA-A5A3-3A2D-17D802F9C4D2}"/>
-                  </a:ext>
-                </a:extLst>
-              </p:cNvPr>
-              <p:cNvSpPr txBox="1"/>
-              <p:nvPr/>
-            </p:nvSpPr>
-            <p:spPr>
-              <a:xfrm>
-                <a:off x="3004358" y="4024746"/>
-                <a:ext cx="287451" cy="276999"/>
-              </a:xfrm>
-              <a:prstGeom prst="rect">
-                <a:avLst/>
-              </a:prstGeom>
-              <a:noFill/>
-            </p:spPr>
-            <p:txBody>
-              <a:bodyPr wrap="none" lIns="0" tIns="0" rIns="0" bIns="0" rtlCol="0">
-                <a:spAutoFit/>
-              </a:bodyPr>
-              <a:lstStyle/>
-              <a:p>
-                <a14:m>
-                  <m:oMathPara xmlns:m="http://schemas.openxmlformats.org/officeDocument/2006/math">
-                    <m:oMathParaPr>
-                      <m:jc m:val="centerGroup"/>
-                    </m:oMathParaPr>
-                    <m:oMath xmlns:m="http://schemas.openxmlformats.org/officeDocument/2006/math">
-                      <m:sSub>
-                        <m:sSubPr>
-                          <m:ctrlPr>
-                            <a:rPr lang="en-US" b="0" i="1" smtClean="0">
-                              <a:latin typeface="Cambria Math" panose="02040503050406030204" pitchFamily="18" charset="0"/>
-                            </a:rPr>
-                          </m:ctrlPr>
-                        </m:sSubPr>
-                        <m:e>
-                          <m:r>
-                            <a:rPr lang="en-US" b="0" i="1" smtClean="0">
-                              <a:latin typeface="Cambria Math" panose="02040503050406030204" pitchFamily="18" charset="0"/>
-                            </a:rPr>
-                            <m:t>𝑋</m:t>
-                          </m:r>
-                        </m:e>
-                        <m:sub>
-                          <m:r>
-                            <a:rPr lang="en-US" b="0" i="1" smtClean="0">
-                              <a:latin typeface="Cambria Math" panose="02040503050406030204" pitchFamily="18" charset="0"/>
-                            </a:rPr>
-                            <m:t>1</m:t>
-                          </m:r>
-                        </m:sub>
-                      </m:sSub>
-                    </m:oMath>
-                  </m:oMathPara>
-                </a14:m>
-                <a:endParaRPr lang="en-US" dirty="0"/>
-              </a:p>
-            </p:txBody>
-          </p:sp>
-        </mc:Choice>
-        <mc:Fallback>
-          <p:sp>
-            <p:nvSpPr>
-              <p:cNvPr id="10" name="TextBox 9">
-                <a:extLst>
-                  <a:ext uri="{FF2B5EF4-FFF2-40B4-BE49-F238E27FC236}">
-                    <a16:creationId xmlns:a16="http://schemas.microsoft.com/office/drawing/2014/main" id="{451AD6D5-55FA-A5A3-3A2D-17D802F9C4D2}"/>
-                  </a:ext>
-                </a:extLst>
-              </p:cNvPr>
-              <p:cNvSpPr txBox="1">
-                <a:spLocks noRot="1" noChangeAspect="1" noMove="1" noResize="1" noEditPoints="1" noAdjustHandles="1" noChangeArrowheads="1" noChangeShapeType="1" noTextEdit="1"/>
-              </p:cNvSpPr>
-              <p:nvPr/>
-            </p:nvSpPr>
-            <p:spPr>
-              <a:xfrm>
-                <a:off x="3004358" y="4024746"/>
-                <a:ext cx="287451" cy="276999"/>
-              </a:xfrm>
-              <a:prstGeom prst="rect">
-                <a:avLst/>
-              </a:prstGeom>
-              <a:blipFill>
-                <a:blip r:embed="rId7"/>
-                <a:stretch>
-                  <a:fillRect l="-21277" r="-8511" b="-15217"/>
-                </a:stretch>
-              </a:blipFill>
-            </p:spPr>
-            <p:txBody>
-              <a:bodyPr/>
-              <a:lstStyle/>
-              <a:p>
-                <a:r>
-                  <a:rPr lang="en-US">
-                    <a:noFill/>
-                  </a:rPr>
-                  <a:t> </a:t>
-                </a:r>
-              </a:p>
-            </p:txBody>
-          </p:sp>
-        </mc:Fallback>
-      </mc:AlternateContent>
-    </p:spTree>
-    <p:extLst>
-      <p:ext uri="{BB962C8B-B14F-4D97-AF65-F5344CB8AC3E}">
-        <p14:creationId xmlns:p14="http://schemas.microsoft.com/office/powerpoint/2010/main" val="4216720913"/>
-      </p:ext>
-    </p:extLst>
-  </p:cSld>
-  <p:clrMapOvr>
-    <a:masterClrMapping/>
-  </p:clrMapOvr>
 </p:sld>
 </file>
 
@@ -20378,10 +21297,10 @@
                               </m:sSubPr>
                               <m:e>
                                 <m:r>
-                                  <a:rPr lang="en-US" b="1" i="1" smtClean="0">
+                                  <a:rPr lang="en-US" b="0" i="1" smtClean="0">
                                     <a:latin typeface="Cambria Math" panose="02040503050406030204" pitchFamily="18" charset="0"/>
                                   </a:rPr>
-                                  <m:t>𝑿</m:t>
+                                  <m:t>𝑦</m:t>
                                 </m:r>
                               </m:e>
                               <m:sub>
@@ -21302,10 +22221,10 @@
                               </m:sSubPr>
                               <m:e>
                                 <m:r>
-                                  <a:rPr lang="en-US" b="1" i="1" smtClean="0">
+                                  <a:rPr lang="en-US" b="0" i="1" smtClean="0">
                                     <a:latin typeface="Cambria Math" panose="02040503050406030204" pitchFamily="18" charset="0"/>
                                   </a:rPr>
-                                  <m:t>𝑿</m:t>
+                                  <m:t>𝑦</m:t>
                                 </m:r>
                               </m:e>
                               <m:sub>

</xml_diff>